<commit_message>
docs: idea PPT v3 — critique fixes: consistent 169x/889x, 45-byte hero, no tech-grid duplication, real repo links, uniform S1, measured v1 numbers
</commit_message>
<xml_diff>
--- a/docs/SIH2026-iTantra-idea-PPT.pptx
+++ b/docs/SIH2026-iTantra-idea-PPT.pptx
@@ -5633,7 +5633,7 @@
         <p:spPr>
           <a:xfrm>
             <a:off x="331286" y="2076450"/>
-            <a:ext cx="5230368" cy="4703019"/>
+            <a:ext cx="5924550" cy="4703019"/>
           </a:xfrm>
           <a:prstGeom prst="rect">
             <a:avLst/>
@@ -5651,11 +5651,11 @@
                 <a:spcPct val="105000"/>
               </a:lnSpc>
               <a:spcAft>
-                <a:spcPts val="900"/>
+                <a:spcPts val="800"/>
               </a:spcAft>
             </a:pPr>
             <a:r>
-              <a:rPr sz="2100" b="1">
+              <a:rPr sz="1800" b="1">
                 <a:solidFill>
                   <a:srgbClr val="262626"/>
                 </a:solidFill>
@@ -5664,7 +5664,7 @@
               <a:t>Problem Statement ID – </a:t>
             </a:r>
             <a:r>
-              <a:rPr sz="2100" b="0">
+              <a:rPr sz="1800" b="0">
                 <a:solidFill>
                   <a:srgbClr val="262626"/>
                 </a:solidFill>
@@ -5680,11 +5680,11 @@
                 <a:spcPct val="105000"/>
               </a:lnSpc>
               <a:spcAft>
-                <a:spcPts val="900"/>
+                <a:spcPts val="800"/>
               </a:spcAft>
             </a:pPr>
             <a:r>
-              <a:rPr sz="1600" b="1">
+              <a:rPr sz="1800" b="1">
                 <a:solidFill>
                   <a:srgbClr val="262626"/>
                 </a:solidFill>
@@ -5693,7 +5693,7 @@
               <a:t>Problem Statement Title- </a:t>
             </a:r>
             <a:r>
-              <a:rPr sz="1600" b="0">
+              <a:rPr sz="1800" b="0">
                 <a:solidFill>
                   <a:srgbClr val="262626"/>
                 </a:solidFill>
@@ -5708,11 +5708,11 @@
                 <a:spcPct val="105000"/>
               </a:lnSpc>
               <a:spcAft>
-                <a:spcPts val="900"/>
+                <a:spcPts val="800"/>
               </a:spcAft>
             </a:pPr>
             <a:r>
-              <a:rPr sz="2100" b="1">
+              <a:rPr sz="1800" b="1">
                 <a:solidFill>
                   <a:srgbClr val="262626"/>
                 </a:solidFill>
@@ -5721,7 +5721,7 @@
               <a:t>Theme- </a:t>
             </a:r>
             <a:r>
-              <a:rPr sz="2100" b="0">
+              <a:rPr sz="1800" b="0">
                 <a:solidFill>
                   <a:srgbClr val="262626"/>
                 </a:solidFill>
@@ -5736,11 +5736,11 @@
                 <a:spcPct val="105000"/>
               </a:lnSpc>
               <a:spcAft>
-                <a:spcPts val="900"/>
+                <a:spcPts val="800"/>
               </a:spcAft>
             </a:pPr>
             <a:r>
-              <a:rPr sz="2100" b="1">
+              <a:rPr sz="1800" b="1">
                 <a:solidFill>
                   <a:srgbClr val="262626"/>
                 </a:solidFill>
@@ -5749,7 +5749,7 @@
               <a:t>PS Category- </a:t>
             </a:r>
             <a:r>
-              <a:rPr sz="2100" b="0">
+              <a:rPr sz="1800" b="0">
                 <a:solidFill>
                   <a:srgbClr val="262626"/>
                 </a:solidFill>
@@ -5764,11 +5764,11 @@
                 <a:spcPct val="105000"/>
               </a:lnSpc>
               <a:spcAft>
-                <a:spcPts val="900"/>
+                <a:spcPts val="800"/>
               </a:spcAft>
             </a:pPr>
             <a:r>
-              <a:rPr sz="2100" b="1">
+              <a:rPr sz="1800" b="1">
                 <a:solidFill>
                   <a:srgbClr val="262626"/>
                 </a:solidFill>
@@ -5777,7 +5777,7 @@
               <a:t>Team ID- </a:t>
             </a:r>
             <a:r>
-              <a:rPr sz="2100" b="0">
+              <a:rPr sz="1800" b="0">
                 <a:solidFill>
                   <a:srgbClr val="262626"/>
                 </a:solidFill>
@@ -5792,11 +5792,11 @@
                 <a:spcPct val="105000"/>
               </a:lnSpc>
               <a:spcAft>
-                <a:spcPts val="900"/>
+                <a:spcPts val="800"/>
               </a:spcAft>
             </a:pPr>
             <a:r>
-              <a:rPr sz="2100" b="1">
+              <a:rPr sz="1800" b="1">
                 <a:solidFill>
                   <a:srgbClr val="262626"/>
                 </a:solidFill>
@@ -5805,7 +5805,7 @@
               <a:t>Team Name- </a:t>
             </a:r>
             <a:r>
-              <a:rPr sz="2100" b="0">
+              <a:rPr sz="1800" b="0">
                 <a:solidFill>
                   <a:srgbClr val="262626"/>
                 </a:solidFill>
@@ -5846,6 +5846,66 @@
           </a:prstGeom>
         </p:spPr>
       </p:pic>
+      <p:sp>
+        <p:nvSpPr>
+          <p:cNvPr id="38" name="Oval 37"/>
+          <p:cNvSpPr/>
+          <p:nvPr/>
+        </p:nvSpPr>
+        <p:spPr>
+          <a:xfrm>
+            <a:off x="91440" y="54864"/>
+            <a:ext cx="1325880" cy="804672"/>
+          </a:xfrm>
+          <a:prstGeom prst="ellipse">
+            <a:avLst/>
+          </a:prstGeom>
+          <a:solidFill>
+            <a:srgbClr val="FFFFFF"/>
+          </a:solidFill>
+          <a:ln w="19050">
+            <a:solidFill>
+              <a:srgbClr val="7B5BA6"/>
+            </a:solidFill>
+          </a:ln>
+          <a:effectLst/>
+        </p:spPr>
+        <p:style>
+          <a:lnRef idx="1">
+            <a:schemeClr val="accent1"/>
+          </a:lnRef>
+          <a:fillRef idx="3">
+            <a:schemeClr val="accent1"/>
+          </a:fillRef>
+          <a:effectRef idx="2">
+            <a:schemeClr val="accent1"/>
+          </a:effectRef>
+          <a:fontRef idx="minor">
+            <a:schemeClr val="lt1"/>
+          </a:fontRef>
+        </p:style>
+        <p:txBody>
+          <a:bodyPr rtlCol="0" anchor="ctr" wrap="square"/>
+          <a:lstStyle/>
+          <a:p>
+            <a:pPr algn="ctr">
+              <a:spcAft>
+                <a:spcPts val="0"/>
+              </a:spcAft>
+            </a:pPr>
+            <a:r>
+              <a:rPr sz="1100" b="1">
+                <a:solidFill>
+                  <a:srgbClr val="262626"/>
+                </a:solidFill>
+                <a:latin typeface="Arial"/>
+              </a:rPr>
+              <a:t>Null
+Pointers</a:t>
+            </a:r>
+          </a:p>
+        </p:txBody>
+      </p:sp>
     </p:spTree>
   </p:cSld>
   <p:clrMapOvr>
@@ -6146,8 +6206,8 @@
         </p:nvSpPr>
         <p:spPr>
           <a:xfrm>
-            <a:off x="91440" y="1152144"/>
-            <a:ext cx="12006072" cy="475488"/>
+            <a:off x="274320" y="1060704"/>
+            <a:ext cx="11658600" cy="566928"/>
           </a:xfrm>
           <a:prstGeom prst="rect">
             <a:avLst/>
@@ -6162,38 +6222,38 @@
           <a:p>
             <a:pPr>
               <a:lnSpc>
-                <a:spcPct val="100000"/>
+                <a:spcPct val="105000"/>
               </a:lnSpc>
               <a:spcAft>
                 <a:spcPts val="400"/>
               </a:spcAft>
             </a:pPr>
             <a:r>
-              <a:rPr sz="1400" b="1">
+              <a:rPr sz="1300" b="1">
                 <a:solidFill>
                   <a:srgbClr val="C55A11"/>
                 </a:solidFill>
                 <a:latin typeface="Arial"/>
               </a:rPr>
-              <a:t>iTantra: </a:t>
-            </a:r>
-            <a:r>
-              <a:rPr sz="1400" b="1">
-                <a:solidFill>
-                  <a:srgbClr val="262626"/>
-                </a:solidFill>
-                <a:latin typeface="Arial"/>
-              </a:rPr>
-              <a:t>any Android phone becomes an offline semantic transceiver — speech → on-device STT (10 languages) → ~45-byte text over any surviving link → natural speech at the far end. </a:t>
-            </a:r>
-            <a:r>
-              <a:rPr sz="1400" b="1">
-                <a:solidFill>
-                  <a:srgbClr val="1F3864"/>
-                </a:solidFill>
-                <a:latin typeface="Arial"/>
-              </a:rPr>
-              <a:t>Voice that travels as text: 165–251× less bandwidth than cellular voice.</a:t>
+              <a:t>iTantra:</a:t>
+            </a:r>
+            <a:r>
+              <a:rPr sz="1300" b="1">
+                <a:solidFill>
+                  <a:srgbClr val="262626"/>
+                </a:solidFill>
+                <a:latin typeface="Arial"/>
+              </a:rPr>
+              <a:t> any Android phone becomes an offline semantic transceiver — speech → on-device STT (10 Indian languages) → ~45-byte text over any surviving link → natural speech at the far end. </a:t>
+            </a:r>
+            <a:r>
+              <a:rPr sz="1300" b="1">
+                <a:solidFill>
+                  <a:srgbClr val="C55A11"/>
+                </a:solidFill>
+                <a:latin typeface="Arial"/>
+              </a:rPr>
+              <a:t>Voice as text: 169× less than cellular voice, 889× less than raw.</a:t>
             </a:r>
           </a:p>
         </p:txBody>
@@ -6214,8 +6274,8 @@
         </p:blipFill>
         <p:spPr>
           <a:xfrm>
-            <a:off x="91440" y="1700784"/>
-            <a:ext cx="9363456" cy="1097280"/>
+            <a:off x="411480" y="1682496"/>
+            <a:ext cx="11338560" cy="1333603"/>
           </a:xfrm>
           <a:prstGeom prst="rect">
             <a:avLst/>
@@ -6224,14 +6284,240 @@
       </p:pic>
       <p:sp>
         <p:nvSpPr>
-          <p:cNvPr id="15364" name="Rounded Rectangle 15363"/>
+          <p:cNvPr id="15364" name="TextBox 15363"/>
+          <p:cNvSpPr txBox="1"/>
+          <p:nvPr/>
+        </p:nvSpPr>
+        <p:spPr>
+          <a:xfrm>
+            <a:off x="411480" y="3090672"/>
+            <a:ext cx="11338560" cy="310896"/>
+          </a:xfrm>
+          <a:prstGeom prst="rect">
+            <a:avLst/>
+          </a:prstGeom>
+          <a:noFill/>
+        </p:spPr>
+        <p:txBody>
+          <a:bodyPr wrap="square">
+            <a:spAutoFit/>
+          </a:bodyPr>
+          <a:lstStyle/>
+          <a:p>
+            <a:pPr algn="ctr">
+              <a:spcAft>
+                <a:spcPts val="400"/>
+              </a:spcAft>
+            </a:pPr>
+            <a:r>
+              <a:rPr sz="1250" b="1">
+                <a:solidFill>
+                  <a:srgbClr val="C55A11"/>
+                </a:solidFill>
+                <a:latin typeface="Arial"/>
+              </a:rPr>
+              <a:t>The app grades itself on stage — live CER · RTF · latency. Measured Hindi round-trip CER: 1.6%.</a:t>
+            </a:r>
+          </a:p>
+        </p:txBody>
+      </p:sp>
+      <p:sp>
+        <p:nvSpPr>
+          <p:cNvPr id="15365" name="TextBox 15364"/>
+          <p:cNvSpPr txBox="1"/>
+          <p:nvPr/>
+        </p:nvSpPr>
+        <p:spPr>
+          <a:xfrm>
+            <a:off x="274320" y="3474720"/>
+            <a:ext cx="7452360" cy="1280160"/>
+          </a:xfrm>
+          <a:prstGeom prst="rect">
+            <a:avLst/>
+          </a:prstGeom>
+          <a:noFill/>
+        </p:spPr>
+        <p:txBody>
+          <a:bodyPr wrap="square">
+            <a:spAutoFit/>
+          </a:bodyPr>
+          <a:lstStyle/>
+          <a:p>
+            <a:pPr>
+              <a:spcAft>
+                <a:spcPts val="300"/>
+              </a:spcAft>
+            </a:pPr>
+            <a:r>
+              <a:rPr sz="1300" b="1">
+                <a:solidFill>
+                  <a:srgbClr val="1F3864"/>
+                </a:solidFill>
+                <a:latin typeface="Arial"/>
+              </a:rPr>
+              <a:t>The Problem We Solve</a:t>
+            </a:r>
+          </a:p>
+          <a:p>
+            <a:pPr>
+              <a:lnSpc>
+                <a:spcPct val="100000"/>
+              </a:lnSpc>
+              <a:spcAft>
+                <a:spcPts val="200"/>
+              </a:spcAft>
+            </a:pPr>
+            <a:r>
+              <a:rPr sz="1050" b="1">
+                <a:solidFill>
+                  <a:srgbClr val="262626"/>
+                </a:solidFill>
+                <a:latin typeface="Arial"/>
+              </a:rPr>
+              <a:t>1. </a:t>
+            </a:r>
+            <a:r>
+              <a:rPr sz="1050" b="1">
+                <a:solidFill>
+                  <a:srgbClr val="262626"/>
+                </a:solidFill>
+                <a:latin typeface="Arial"/>
+              </a:rPr>
+              <a:t>Towers die in disasters: </a:t>
+            </a:r>
+            <a:r>
+              <a:rPr sz="1050" b="0">
+                <a:solidFill>
+                  <a:srgbClr val="262626"/>
+                </a:solidFill>
+                <a:latin typeface="Arial"/>
+              </a:rPr>
+              <a:t>Amphan knocked out ~7,000 of 14,167 WB cell towers; 65–70% capacity for days (COAI).</a:t>
+            </a:r>
+          </a:p>
+          <a:p>
+            <a:pPr>
+              <a:lnSpc>
+                <a:spcPct val="100000"/>
+              </a:lnSpc>
+              <a:spcAft>
+                <a:spcPts val="200"/>
+              </a:spcAft>
+            </a:pPr>
+            <a:r>
+              <a:rPr sz="1050" b="1">
+                <a:solidFill>
+                  <a:srgbClr val="262626"/>
+                </a:solidFill>
+                <a:latin typeface="Arial"/>
+              </a:rPr>
+              <a:t>2. </a:t>
+            </a:r>
+            <a:r>
+              <a:rPr sz="1050" b="1">
+                <a:solidFill>
+                  <a:srgbClr val="262626"/>
+                </a:solidFill>
+                <a:latin typeface="Arial"/>
+              </a:rPr>
+              <a:t>Text alerts miss the vulnerable: </a:t>
+            </a:r>
+            <a:r>
+              <a:rPr sz="1050" b="0">
+                <a:solidFill>
+                  <a:srgbClr val="262626"/>
+                </a:solidFill>
+                <a:latin typeface="Arial"/>
+              </a:rPr>
+              <a:t>rural female literacy ~50.6% — silent SMS under-reaches disaster-prone belts.</a:t>
+            </a:r>
+          </a:p>
+          <a:p>
+            <a:pPr>
+              <a:lnSpc>
+                <a:spcPct val="100000"/>
+              </a:lnSpc>
+              <a:spcAft>
+                <a:spcPts val="200"/>
+              </a:spcAft>
+            </a:pPr>
+            <a:r>
+              <a:rPr sz="1050" b="1">
+                <a:solidFill>
+                  <a:srgbClr val="262626"/>
+                </a:solidFill>
+                <a:latin typeface="Arial"/>
+              </a:rPr>
+              <a:t>3. </a:t>
+            </a:r>
+            <a:r>
+              <a:rPr sz="1050" b="1">
+                <a:solidFill>
+                  <a:srgbClr val="262626"/>
+                </a:solidFill>
+                <a:latin typeface="Arial"/>
+              </a:rPr>
+              <a:t>Language exclusion: </a:t>
+            </a:r>
+            <a:r>
+              <a:rPr sz="1050" b="0">
+                <a:solidFill>
+                  <a:srgbClr val="262626"/>
+                </a:solidFill>
+                <a:latin typeface="Arial"/>
+              </a:rPr>
+              <a:t>~90% of rural India communicates only in its mother tongue (22 scheduled languages).</a:t>
+            </a:r>
+          </a:p>
+          <a:p>
+            <a:pPr>
+              <a:lnSpc>
+                <a:spcPct val="100000"/>
+              </a:lnSpc>
+              <a:spcAft>
+                <a:spcPts val="200"/>
+              </a:spcAft>
+            </a:pPr>
+            <a:r>
+              <a:rPr sz="1050" b="1">
+                <a:solidFill>
+                  <a:srgbClr val="262626"/>
+                </a:solidFill>
+                <a:latin typeface="Arial"/>
+              </a:rPr>
+              <a:t>4. </a:t>
+            </a:r>
+            <a:r>
+              <a:rPr sz="1050" b="1">
+                <a:solidFill>
+                  <a:srgbClr val="262626"/>
+                </a:solidFill>
+                <a:latin typeface="Arial"/>
+              </a:rPr>
+              <a:t>Voice is too heavy for weak links: </a:t>
+            </a:r>
+            <a:r>
+              <a:rPr sz="1050" b="0">
+                <a:solidFill>
+                  <a:srgbClr val="262626"/>
+                </a:solidFill>
+                <a:latin typeface="Arial"/>
+              </a:rPr>
+              <a:t>raw voice is 64,000 bps; even NATO’s MELPe needs 600 bps.</a:t>
+            </a:r>
+          </a:p>
+        </p:txBody>
+      </p:sp>
+      <p:sp>
+        <p:nvSpPr>
+          <p:cNvPr id="15366" name="Rounded Rectangle 15365"/>
           <p:cNvSpPr/>
           <p:nvPr/>
         </p:nvSpPr>
         <p:spPr>
           <a:xfrm>
-            <a:off x="9564624" y="1700784"/>
-            <a:ext cx="2724912" cy="2231136"/>
+            <a:off x="7863840" y="3474720"/>
+            <a:ext cx="3931920" cy="1298448"/>
           </a:xfrm>
           <a:prstGeom prst="roundRect">
             <a:avLst/>
@@ -6261,16 +6547,16 @@
           </a:fontRef>
         </p:style>
         <p:txBody>
-          <a:bodyPr rtlCol="0" anchor="ctr" wrap="square" tIns="54864"/>
+          <a:bodyPr rtlCol="0" anchor="ctr" wrap="square" bIns="36576"/>
           <a:lstStyle/>
           <a:p>
             <a:pPr algn="ctr">
               <a:spcAft>
-                <a:spcPts val="300"/>
+                <a:spcPts val="400"/>
               </a:spcAft>
             </a:pPr>
             <a:r>
-              <a:rPr sz="1250" b="1">
+              <a:rPr sz="1300" b="1">
                 <a:solidFill>
                   <a:srgbClr val="C55A11"/>
                 </a:solidFill>
@@ -6282,14 +6568,14 @@
           <a:p>
             <a:pPr>
               <a:lnSpc>
-                <a:spcPct val="100000"/>
+                <a:spcPct val="105000"/>
               </a:lnSpc>
               <a:spcAft>
-                <a:spcPts val="350"/>
+                <a:spcPts val="500"/>
               </a:spcAft>
             </a:pPr>
             <a:r>
-              <a:rPr sz="1000" b="1">
+              <a:rPr sz="1100" b="1">
                 <a:solidFill>
                   <a:srgbClr val="262626"/>
                 </a:solidFill>
@@ -6298,26 +6584,26 @@
               <a:t>1. </a:t>
             </a:r>
             <a:r>
-              <a:rPr sz="1000" b="1">
-                <a:solidFill>
-                  <a:srgbClr val="262626"/>
-                </a:solidFill>
-                <a:latin typeface="Arial"/>
-              </a:rPr>
-              <a:t>Text is the codec — 165–251× smaller</a:t>
+              <a:rPr sz="1100" b="1">
+                <a:solidFill>
+                  <a:srgbClr val="262626"/>
+                </a:solidFill>
+                <a:latin typeface="Arial"/>
+              </a:rPr>
+              <a:t>Text is the codec — 169× less than cellular voice</a:t>
             </a:r>
           </a:p>
           <a:p>
             <a:pPr>
               <a:lnSpc>
-                <a:spcPct val="100000"/>
+                <a:spcPct val="105000"/>
               </a:lnSpc>
               <a:spcAft>
-                <a:spcPts val="350"/>
+                <a:spcPts val="0"/>
               </a:spcAft>
             </a:pPr>
             <a:r>
-              <a:rPr sz="1000" b="1">
+              <a:rPr sz="1100" b="1">
                 <a:solidFill>
                   <a:srgbClr val="262626"/>
                 </a:solidFill>
@@ -6326,111 +6612,27 @@
               <a:t>2. </a:t>
             </a:r>
             <a:r>
-              <a:rPr sz="1000" b="1">
-                <a:solidFill>
-                  <a:srgbClr val="262626"/>
-                </a:solidFill>
-                <a:latin typeface="Arial"/>
-              </a:rPr>
-              <a:t>VarnaCode — built for Indic scripts</a:t>
-            </a:r>
-          </a:p>
-          <a:p>
-            <a:pPr>
-              <a:lnSpc>
-                <a:spcPct val="100000"/>
-              </a:lnSpc>
-              <a:spcAft>
-                <a:spcPts val="350"/>
-              </a:spcAft>
-            </a:pPr>
-            <a:r>
-              <a:rPr sz="1000" b="1">
-                <a:solidFill>
-                  <a:srgbClr val="262626"/>
-                </a:solidFill>
-                <a:latin typeface="Arial"/>
-              </a:rPr>
-              <a:t>3. </a:t>
-            </a:r>
-            <a:r>
-              <a:rPr sz="1000" b="1">
-                <a:solidFill>
-                  <a:srgbClr val="262626"/>
-                </a:solidFill>
-                <a:latin typeface="Arial"/>
-              </a:rPr>
-              <a:t>Evaluation Mode — rubric on stage</a:t>
-            </a:r>
-          </a:p>
-          <a:p>
-            <a:pPr>
-              <a:lnSpc>
-                <a:spcPct val="100000"/>
-              </a:lnSpc>
-              <a:spcAft>
-                <a:spcPts val="350"/>
-              </a:spcAft>
-            </a:pPr>
-            <a:r>
-              <a:rPr sz="1000" b="1">
-                <a:solidFill>
-                  <a:srgbClr val="262626"/>
-                </a:solidFill>
-                <a:latin typeface="Arial"/>
-              </a:rPr>
-              <a:t>4. </a:t>
-            </a:r>
-            <a:r>
-              <a:rPr sz="1000" b="1">
-                <a:solidFill>
-                  <a:srgbClr val="262626"/>
-                </a:solidFill>
-                <a:latin typeface="Arial"/>
-              </a:rPr>
-              <a:t>₹1,650 LoRa bridge — link made real</a:t>
-            </a:r>
-          </a:p>
-          <a:p>
-            <a:pPr>
-              <a:lnSpc>
-                <a:spcPct val="100000"/>
-              </a:lnSpc>
-              <a:spcAft>
-                <a:spcPts val="350"/>
-              </a:spcAft>
-            </a:pPr>
-            <a:r>
-              <a:rPr sz="1000" b="1">
-                <a:solidFill>
-                  <a:srgbClr val="262626"/>
-                </a:solidFill>
-                <a:latin typeface="Arial"/>
-              </a:rPr>
-              <a:t>5. </a:t>
-            </a:r>
-            <a:r>
-              <a:rPr sz="1000" b="1">
-                <a:solidFill>
-                  <a:srgbClr val="262626"/>
-                </a:solidFill>
-                <a:latin typeface="Arial"/>
-              </a:rPr>
-              <a:t>100% offline Bhashini-lineage AI</a:t>
-            </a:r>
-          </a:p>
-        </p:txBody>
-      </p:sp>
-      <p:sp>
-        <p:nvSpPr>
-          <p:cNvPr id="15365" name="TextBox 15364"/>
+              <a:rPr sz="1100" b="1">
+                <a:solidFill>
+                  <a:srgbClr val="262626"/>
+                </a:solidFill>
+                <a:latin typeface="Arial"/>
+              </a:rPr>
+              <a:t>VarnaCode — Indic compression at the entropy floor</a:t>
+            </a:r>
+          </a:p>
+        </p:txBody>
+      </p:sp>
+      <p:sp>
+        <p:nvSpPr>
+          <p:cNvPr id="15367" name="TextBox 15366"/>
           <p:cNvSpPr txBox="1"/>
           <p:nvPr/>
         </p:nvSpPr>
         <p:spPr>
           <a:xfrm>
-            <a:off x="91440" y="2944368"/>
-            <a:ext cx="12006072" cy="1097280"/>
+            <a:off x="274320" y="4828032"/>
+            <a:ext cx="11521440" cy="1481328"/>
           </a:xfrm>
           <a:prstGeom prst="rect">
             <a:avLst/>
@@ -6445,7 +6647,7 @@
           <a:p>
             <a:pPr>
               <a:spcAft>
-                <a:spcPts val="250"/>
+                <a:spcPts val="300"/>
               </a:spcAft>
             </a:pPr>
             <a:r>
@@ -6455,7 +6657,7 @@
                 </a:solidFill>
                 <a:latin typeface="Arial"/>
               </a:rPr>
-              <a:t>The Problem We Solve</a:t>
+              <a:t>How iTantra Solves It</a:t>
             </a:r>
           </a:p>
           <a:p>
@@ -6468,7 +6670,7 @@
               </a:spcAft>
             </a:pPr>
             <a:r>
-              <a:rPr sz="1150" b="1">
+              <a:rPr sz="1050" b="1">
                 <a:solidFill>
                   <a:srgbClr val="262626"/>
                 </a:solidFill>
@@ -6477,22 +6679,22 @@
               <a:t>1. </a:t>
             </a:r>
             <a:r>
-              <a:rPr sz="1150" b="1">
-                <a:solidFill>
-                  <a:srgbClr val="262626"/>
-                </a:solidFill>
-                <a:latin typeface="Arial"/>
-              </a:rPr>
-              <a:t>Towers die in disasters: </a:t>
-            </a:r>
-            <a:r>
-              <a:rPr sz="1150" b="0">
-                <a:solidFill>
-                  <a:srgbClr val="262626"/>
-                </a:solidFill>
-                <a:latin typeface="Arial"/>
-              </a:rPr>
-              <a:t>Cyclone Amphan downed ~7,000 of 14,167 WB cell towers; networks at 65–70% capacity for days (COAI).</a:t>
+              <a:rPr sz="1050" b="1">
+                <a:solidFill>
+                  <a:srgbClr val="262626"/>
+                </a:solidFill>
+                <a:latin typeface="Arial"/>
+              </a:rPr>
+              <a:t>On-device STT with pause-aware sentences: </a:t>
+            </a:r>
+            <a:r>
+              <a:rPr sz="1050" b="0">
+                <a:solidFill>
+                  <a:srgbClr val="262626"/>
+                </a:solidFill>
+                <a:latin typeface="Arial"/>
+              </a:rPr>
+              <a:t>IndicConformer int8 (MIT) ×9 + Whisper English; Silero VAD streams sentences mid-hold — fully offline.</a:t>
             </a:r>
           </a:p>
           <a:p>
@@ -6505,7 +6707,7 @@
               </a:spcAft>
             </a:pPr>
             <a:r>
-              <a:rPr sz="1150" b="1">
+              <a:rPr sz="1050" b="1">
                 <a:solidFill>
                   <a:srgbClr val="262626"/>
                 </a:solidFill>
@@ -6514,22 +6716,22 @@
               <a:t>2. </a:t>
             </a:r>
             <a:r>
-              <a:rPr sz="1150" b="1">
-                <a:solidFill>
-                  <a:srgbClr val="262626"/>
-                </a:solidFill>
-                <a:latin typeface="Arial"/>
-              </a:rPr>
-              <a:t>Text alerts miss the vulnerable: </a:t>
-            </a:r>
-            <a:r>
-              <a:rPr sz="1150" b="0">
-                <a:solidFill>
-                  <a:srgbClr val="262626"/>
-                </a:solidFill>
-                <a:latin typeface="Arial"/>
-              </a:rPr>
-              <a:t>rural female literacy ~50.6% — silent SMS structurally under-reaches the disaster-prone belts.</a:t>
+              <a:rPr sz="1050" b="1">
+                <a:solidFill>
+                  <a:srgbClr val="262626"/>
+                </a:solidFill>
+                <a:latin typeface="Arial"/>
+              </a:rPr>
+              <a:t>VarnaCode over any bearer: </a:t>
+            </a:r>
+            <a:r>
+              <a:rPr sz="1050" b="0">
+                <a:solidFill>
+                  <a:srgbClr val="262626"/>
+                </a:solidFill>
+                <a:latin typeface="Arial"/>
+              </a:rPr>
+              <a:t>measured 4.45–5.36 bits/char (all 10 languages) — a sentence in ~45 B via Wi-Fi (NSD+TCP) · Bluetooth RFCOMM · ₹1,650 LoRa (km-range, IN865).</a:t>
             </a:r>
           </a:p>
           <a:p>
@@ -6542,7 +6744,7 @@
               </a:spcAft>
             </a:pPr>
             <a:r>
-              <a:rPr sz="1150" b="1">
+              <a:rPr sz="1050" b="1">
                 <a:solidFill>
                   <a:srgbClr val="262626"/>
                 </a:solidFill>
@@ -6551,22 +6753,22 @@
               <a:t>3. </a:t>
             </a:r>
             <a:r>
-              <a:rPr sz="1150" b="1">
-                <a:solidFill>
-                  <a:srgbClr val="262626"/>
-                </a:solidFill>
-                <a:latin typeface="Arial"/>
-              </a:rPr>
-              <a:t>Language exclusion: </a:t>
-            </a:r>
-            <a:r>
-              <a:rPr sz="1150" b="0">
-                <a:solidFill>
-                  <a:srgbClr val="262626"/>
-                </a:solidFill>
-                <a:latin typeface="Arial"/>
-              </a:rPr>
-              <a:t>~90% of rural India communicates only in its mother tongue, across 22 scheduled languages.</a:t>
+              <a:rPr sz="1050" b="1">
+                <a:solidFill>
+                  <a:srgbClr val="262626"/>
+                </a:solidFill>
+                <a:latin typeface="Arial"/>
+              </a:rPr>
+              <a:t>Natural voice out: </a:t>
+            </a:r>
+            <a:r>
+              <a:rPr sz="1050" b="0">
+                <a:solidFill>
+                  <a:srgbClr val="262626"/>
+                </a:solidFill>
+                <a:latin typeface="Arial"/>
+              </a:rPr>
+              <a:t>AI4Bharat FastPitch + Piper TTS (MIT), sentence-streamed; eSpeak-NG fallback — never silent.</a:t>
             </a:r>
           </a:p>
           <a:p>
@@ -6579,7 +6781,7 @@
               </a:spcAft>
             </a:pPr>
             <a:r>
-              <a:rPr sz="1150" b="1">
+              <a:rPr sz="1050" b="1">
                 <a:solidFill>
                   <a:srgbClr val="262626"/>
                 </a:solidFill>
@@ -6588,61 +6790,22 @@
               <a:t>4. </a:t>
             </a:r>
             <a:r>
-              <a:rPr sz="1150" b="1">
-                <a:solidFill>
-                  <a:srgbClr val="262626"/>
-                </a:solidFill>
-                <a:latin typeface="Arial"/>
-              </a:rPr>
-              <a:t>Voice is too heavy for weak links: </a:t>
-            </a:r>
-            <a:r>
-              <a:rPr sz="1150" b="0">
-                <a:solidFill>
-                  <a:srgbClr val="262626"/>
-                </a:solidFill>
-                <a:latin typeface="Arial"/>
-              </a:rPr>
-              <a:t>raw voice is 64,000 bps; even NATO’s MELPe battlefield codec needs 600 bps.</a:t>
-            </a:r>
-          </a:p>
-        </p:txBody>
-      </p:sp>
-      <p:sp>
-        <p:nvSpPr>
-          <p:cNvPr id="15366" name="TextBox 15365"/>
-          <p:cNvSpPr txBox="1"/>
-          <p:nvPr/>
-        </p:nvSpPr>
-        <p:spPr>
-          <a:xfrm>
-            <a:off x="91440" y="4078224"/>
-            <a:ext cx="12006072" cy="2212848"/>
-          </a:xfrm>
-          <a:prstGeom prst="rect">
-            <a:avLst/>
-          </a:prstGeom>
-          <a:noFill/>
-        </p:spPr>
-        <p:txBody>
-          <a:bodyPr wrap="square">
-            <a:spAutoFit/>
-          </a:bodyPr>
-          <a:lstStyle/>
-          <a:p>
-            <a:pPr>
-              <a:spcAft>
-                <a:spcPts val="250"/>
-              </a:spcAft>
-            </a:pPr>
-            <a:r>
-              <a:rPr sz="1300" b="1">
-                <a:solidFill>
-                  <a:srgbClr val="1F3864"/>
-                </a:solidFill>
-                <a:latin typeface="Arial"/>
-              </a:rPr>
-              <a:t>How iTantra Solves It</a:t>
+              <a:rPr sz="1050" b="1">
+                <a:solidFill>
+                  <a:srgbClr val="262626"/>
+                </a:solidFill>
+                <a:latin typeface="Arial"/>
+              </a:rPr>
+              <a:t>Alert mode: </a:t>
+            </a:r>
+            <a:r>
+              <a:rPr sz="1050" b="0">
+                <a:solidFill>
+                  <a:srgbClr val="262626"/>
+                </a:solidFill>
+                <a:latin typeface="Arial"/>
+              </a:rPr>
+              <a:t>priority frames auto-play at max volume, non-interruptible, with a place-name pronunciation lexicon.</a:t>
             </a:r>
           </a:p>
           <a:p>
@@ -6655,155 +6818,7 @@
               </a:spcAft>
             </a:pPr>
             <a:r>
-              <a:rPr sz="1100" b="1">
-                <a:solidFill>
-                  <a:srgbClr val="262626"/>
-                </a:solidFill>
-                <a:latin typeface="Arial"/>
-              </a:rPr>
-              <a:t>1. </a:t>
-            </a:r>
-            <a:r>
-              <a:rPr sz="1100" b="1">
-                <a:solidFill>
-                  <a:srgbClr val="262626"/>
-                </a:solidFill>
-                <a:latin typeface="Arial"/>
-              </a:rPr>
-              <a:t>On-device STT: </a:t>
-            </a:r>
-            <a:r>
-              <a:rPr sz="1100" b="0">
-                <a:solidFill>
-                  <a:srgbClr val="262626"/>
-                </a:solidFill>
-                <a:latin typeface="Arial"/>
-              </a:rPr>
-              <a:t>AI4Bharat IndicConformer int8 (MIT) ×9 Indic + English — measured RTF 0.055–0.119, fully offline.</a:t>
-            </a:r>
-          </a:p>
-          <a:p>
-            <a:pPr>
-              <a:lnSpc>
-                <a:spcPct val="100000"/>
-              </a:lnSpc>
-              <a:spcAft>
-                <a:spcPts val="200"/>
-              </a:spcAft>
-            </a:pPr>
-            <a:r>
-              <a:rPr sz="1100" b="1">
-                <a:solidFill>
-                  <a:srgbClr val="262626"/>
-                </a:solidFill>
-                <a:latin typeface="Arial"/>
-              </a:rPr>
-              <a:t>2. </a:t>
-            </a:r>
-            <a:r>
-              <a:rPr sz="1100" b="1">
-                <a:solidFill>
-                  <a:srgbClr val="262626"/>
-                </a:solidFill>
-                <a:latin typeface="Arial"/>
-              </a:rPr>
-              <a:t>Pause-aware sentences: </a:t>
-            </a:r>
-            <a:r>
-              <a:rPr sz="1100" b="0">
-                <a:solidFill>
-                  <a:srgbClr val="262626"/>
-                </a:solidFill>
-                <a:latin typeface="Arial"/>
-              </a:rPr>
-              <a:t>Silero VAD chunks speech into sentences mid-hold, streamed as they form.</a:t>
-            </a:r>
-          </a:p>
-          <a:p>
-            <a:pPr>
-              <a:lnSpc>
-                <a:spcPct val="100000"/>
-              </a:lnSpc>
-              <a:spcAft>
-                <a:spcPts val="200"/>
-              </a:spcAft>
-            </a:pPr>
-            <a:r>
-              <a:rPr sz="1100" b="1">
-                <a:solidFill>
-                  <a:srgbClr val="262626"/>
-                </a:solidFill>
-                <a:latin typeface="Arial"/>
-              </a:rPr>
-              <a:t>3. </a:t>
-            </a:r>
-            <a:r>
-              <a:rPr sz="1100" b="1">
-                <a:solidFill>
-                  <a:srgbClr val="262626"/>
-                </a:solidFill>
-                <a:latin typeface="Arial"/>
-              </a:rPr>
-              <a:t>VarnaCode: </a:t>
-            </a:r>
-            <a:r>
-              <a:rPr sz="1100" b="0">
-                <a:solidFill>
-                  <a:srgbClr val="262626"/>
-                </a:solidFill>
-                <a:latin typeface="Arial"/>
-              </a:rPr>
-              <a:t>Indic-script entropy coding, measured 4.6–5.3 bits/char — a spoken sentence in ~45 bytes = one LoRa frame.</a:t>
-            </a:r>
-          </a:p>
-          <a:p>
-            <a:pPr>
-              <a:lnSpc>
-                <a:spcPct val="100000"/>
-              </a:lnSpc>
-              <a:spcAft>
-                <a:spcPts val="200"/>
-              </a:spcAft>
-            </a:pPr>
-            <a:r>
-              <a:rPr sz="1100" b="1">
-                <a:solidFill>
-                  <a:srgbClr val="262626"/>
-                </a:solidFill>
-                <a:latin typeface="Arial"/>
-              </a:rPr>
-              <a:t>4. </a:t>
-            </a:r>
-            <a:r>
-              <a:rPr sz="1100" b="1">
-                <a:solidFill>
-                  <a:srgbClr val="262626"/>
-                </a:solidFill>
-                <a:latin typeface="Arial"/>
-              </a:rPr>
-              <a:t>Natural voice out: </a:t>
-            </a:r>
-            <a:r>
-              <a:rPr sz="1100" b="0">
-                <a:solidFill>
-                  <a:srgbClr val="262626"/>
-                </a:solidFill>
-                <a:latin typeface="Arial"/>
-              </a:rPr>
-              <a:t>AI4Bharat FastPitch + Piper TTS (MIT), measured RTF 0.049; eSpeak-NG fallback — never silent.</a:t>
-            </a:r>
-          </a:p>
-          <a:p>
-            <a:pPr>
-              <a:lnSpc>
-                <a:spcPct val="100000"/>
-              </a:lnSpc>
-              <a:spcAft>
-                <a:spcPts val="200"/>
-              </a:spcAft>
-            </a:pPr>
-            <a:r>
-              <a:rPr sz="1100" b="1">
+              <a:rPr sz="1050" b="1">
                 <a:solidFill>
                   <a:srgbClr val="262626"/>
                 </a:solidFill>
@@ -6812,44 +6827,7 @@
               <a:t>5. </a:t>
             </a:r>
             <a:r>
-              <a:rPr sz="1100" b="1">
-                <a:solidFill>
-                  <a:srgbClr val="262626"/>
-                </a:solidFill>
-                <a:latin typeface="Arial"/>
-              </a:rPr>
-              <a:t>Alert mode: </a:t>
-            </a:r>
-            <a:r>
-              <a:rPr sz="1100" b="0">
-                <a:solidFill>
-                  <a:srgbClr val="262626"/>
-                </a:solidFill>
-                <a:latin typeface="Arial"/>
-              </a:rPr>
-              <a:t>priority frames auto-play at max volume, non-interruptible, with a place-name pronunciation lexicon.</a:t>
-            </a:r>
-          </a:p>
-          <a:p>
-            <a:pPr>
-              <a:lnSpc>
-                <a:spcPct val="100000"/>
-              </a:lnSpc>
-              <a:spcAft>
-                <a:spcPts val="200"/>
-              </a:spcAft>
-            </a:pPr>
-            <a:r>
-              <a:rPr sz="1100" b="1">
-                <a:solidFill>
-                  <a:srgbClr val="262626"/>
-                </a:solidFill>
-                <a:latin typeface="Arial"/>
-              </a:rPr>
-              <a:t>6. </a:t>
-            </a:r>
-            <a:r>
-              <a:rPr sz="1100" b="1">
+              <a:rPr sz="1050" b="1">
                 <a:solidFill>
                   <a:srgbClr val="262626"/>
                 </a:solidFill>
@@ -6858,87 +6836,13 @@
               <a:t>Walkie-talkie loop: </a:t>
             </a:r>
             <a:r>
-              <a:rPr sz="1100" b="0">
+              <a:rPr sz="1050" b="0">
                 <a:solidFill>
                   <a:srgbClr val="262626"/>
                 </a:solidFill>
                 <a:latin typeface="Arial"/>
               </a:rPr>
               <a:t>two phones, push-to-talk: STT mode ↔ TTS mode; app off = normal phone (the PS verification loop).</a:t>
-            </a:r>
-          </a:p>
-          <a:p>
-            <a:pPr>
-              <a:lnSpc>
-                <a:spcPct val="100000"/>
-              </a:lnSpc>
-              <a:spcAft>
-                <a:spcPts val="200"/>
-              </a:spcAft>
-            </a:pPr>
-            <a:r>
-              <a:rPr sz="1100" b="1">
-                <a:solidFill>
-                  <a:srgbClr val="262626"/>
-                </a:solidFill>
-                <a:latin typeface="Arial"/>
-              </a:rPr>
-              <a:t>7. </a:t>
-            </a:r>
-            <a:r>
-              <a:rPr sz="1100" b="1">
-                <a:solidFill>
-                  <a:srgbClr val="262626"/>
-                </a:solidFill>
-                <a:latin typeface="Arial"/>
-              </a:rPr>
-              <a:t>Any bearer: </a:t>
-            </a:r>
-            <a:r>
-              <a:rPr sz="1100" b="0">
-                <a:solidFill>
-                  <a:srgbClr val="262626"/>
-                </a:solidFill>
-                <a:latin typeface="Arial"/>
-              </a:rPr>
-              <a:t>Wi-Fi (NSD+TCP) · Bluetooth RFCOMM · ₹1,650 ESP32-LoRa bridge (km-range, IN865 license-free).</a:t>
-            </a:r>
-          </a:p>
-          <a:p>
-            <a:pPr>
-              <a:lnSpc>
-                <a:spcPct val="100000"/>
-              </a:lnSpc>
-              <a:spcAft>
-                <a:spcPts val="200"/>
-              </a:spcAft>
-            </a:pPr>
-            <a:r>
-              <a:rPr sz="1100" b="1">
-                <a:solidFill>
-                  <a:srgbClr val="262626"/>
-                </a:solidFill>
-                <a:latin typeface="Arial"/>
-              </a:rPr>
-              <a:t>8. </a:t>
-            </a:r>
-            <a:r>
-              <a:rPr sz="1100" b="1">
-                <a:solidFill>
-                  <a:srgbClr val="262626"/>
-                </a:solidFill>
-                <a:latin typeface="Arial"/>
-              </a:rPr>
-              <a:t>Live Evaluation Mode: </a:t>
-            </a:r>
-            <a:r>
-              <a:rPr sz="1100" b="0">
-                <a:solidFill>
-                  <a:srgbClr val="262626"/>
-                </a:solidFill>
-                <a:latin typeface="Arial"/>
-              </a:rPr>
-              <a:t>the app measures its own CER/RTF/latency — measured Hindi round-trip CER 1.6%.</a:t>
             </a:r>
           </a:p>
         </p:txBody>
@@ -7229,8 +7133,8 @@
         </p:nvSpPr>
         <p:spPr>
           <a:xfrm>
-            <a:off x="210312" y="868680"/>
-            <a:ext cx="6035040" cy="5394960"/>
+            <a:off x="256032" y="987552"/>
+            <a:ext cx="5212080" cy="5257800"/>
           </a:xfrm>
           <a:prstGeom prst="rect">
             <a:avLst/>
@@ -7245,30 +7149,67 @@
           <a:p>
             <a:pPr>
               <a:spcAft>
+                <a:spcPts val="300"/>
+              </a:spcAft>
+            </a:pPr>
+            <a:r>
+              <a:rPr sz="1250" b="1">
+                <a:solidFill>
+                  <a:srgbClr val="1F3864"/>
+                </a:solidFill>
+                <a:latin typeface="Arial"/>
+              </a:rPr>
+              <a:t>Technologies</a:t>
+            </a:r>
+          </a:p>
+          <a:p>
+            <a:pPr>
+              <a:lnSpc>
+                <a:spcPct val="102000"/>
+              </a:lnSpc>
+              <a:spcAft>
                 <a:spcPts val="350"/>
               </a:spcAft>
             </a:pPr>
             <a:r>
-              <a:rPr sz="1300" b="1">
-                <a:solidFill>
-                  <a:srgbClr val="1F3864"/>
-                </a:solidFill>
-                <a:latin typeface="Arial"/>
-              </a:rPr>
-              <a:t>Technologies</a:t>
+              <a:rPr sz="1100" b="0">
+                <a:solidFill>
+                  <a:srgbClr val="262626"/>
+                </a:solidFill>
+                <a:latin typeface="Arial"/>
+              </a:rPr>
+              <a:t>• </a:t>
+            </a:r>
+            <a:r>
+              <a:rPr sz="1100" b="1">
+                <a:solidFill>
+                  <a:srgbClr val="262626"/>
+                </a:solidFill>
+                <a:latin typeface="Arial"/>
+              </a:rPr>
+              <a:t>Native Kotlin + Jetpack Compose; </a:t>
+            </a:r>
+            <a:r>
+              <a:rPr sz="1100" b="0">
+                <a:solidFill>
+                  <a:srgbClr val="262626"/>
+                </a:solidFill>
+                <a:latin typeface="Arial"/>
+              </a:rPr>
+              <a:t>foreground service (mic type) + audio-focus discipline for Android 14+; APK 54 MB incl. full speech runtime.</a:t>
             </a:r>
           </a:p>
           <a:p>
             <a:pPr>
               <a:lnSpc>
-                <a:spcPct val="100000"/>
+                <a:spcPct val="102000"/>
               </a:lnSpc>
               <a:spcAft>
-                <a:spcPts val="600"/>
+                <a:spcPts val="350"/>
               </a:spcAft>
             </a:pPr>
             <a:r>
-              <a:rPr sz="1200" b="0">
+              <a:rPr sz="1100" b="0">
                 <a:solidFill>
                   <a:srgbClr val="262626"/>
                 </a:solidFill>
@@ -7277,35 +7218,35 @@
               <a:t>• </a:t>
             </a:r>
             <a:r>
-              <a:rPr sz="1200" b="1">
-                <a:solidFill>
-                  <a:srgbClr val="262626"/>
-                </a:solidFill>
-                <a:latin typeface="Arial"/>
-              </a:rPr>
-              <a:t>Native Kotlin + Jetpack Compose — </a:t>
-            </a:r>
-            <a:r>
-              <a:rPr sz="1200" b="0">
-                <a:solidFill>
-                  <a:srgbClr val="262626"/>
-                </a:solidFill>
-                <a:latin typeface="Arial"/>
-              </a:rPr>
-              <a:t>foreground service (mic) + audio-focus discipline for Android 14+; APK spine 878 KB, 7 JUnit tests green.</a:t>
+              <a:rPr sz="1100" b="1">
+                <a:solidFill>
+                  <a:srgbClr val="262626"/>
+                </a:solidFill>
+                <a:latin typeface="Arial"/>
+              </a:rPr>
+              <a:t>sherpa-onnx v1.13.6 (Apache-2.0): </a:t>
+            </a:r>
+            <a:r>
+              <a:rPr sz="1100" b="0">
+                <a:solidFill>
+                  <a:srgbClr val="262626"/>
+                </a:solidFill>
+                <a:latin typeface="Arial"/>
+              </a:rPr>
+              <a:t>one JNI surface for STT + TTS + VAD — 14.5k★, active.</a:t>
             </a:r>
           </a:p>
           <a:p>
             <a:pPr>
               <a:lnSpc>
-                <a:spcPct val="100000"/>
+                <a:spcPct val="102000"/>
               </a:lnSpc>
               <a:spcAft>
-                <a:spcPts val="600"/>
+                <a:spcPts val="350"/>
               </a:spcAft>
             </a:pPr>
             <a:r>
-              <a:rPr sz="1200" b="0">
+              <a:rPr sz="1100" b="0">
                 <a:solidFill>
                   <a:srgbClr val="262626"/>
                 </a:solidFill>
@@ -7314,35 +7255,35 @@
               <a:t>• </a:t>
             </a:r>
             <a:r>
-              <a:rPr sz="1200" b="1">
-                <a:solidFill>
-                  <a:srgbClr val="262626"/>
-                </a:solidFill>
-                <a:latin typeface="Arial"/>
-              </a:rPr>
-              <a:t>sherpa-onnx (Apache-2.0): </a:t>
-            </a:r>
-            <a:r>
-              <a:rPr sz="1200" b="0">
-                <a:solidFill>
-                  <a:srgbClr val="262626"/>
-                </a:solidFill>
-                <a:latin typeface="Arial"/>
-              </a:rPr>
-              <a:t>one JNI surface for STT + TTS + VAD — 14.5k★, actively maintained.</a:t>
+              <a:rPr sz="1100" b="1">
+                <a:solidFill>
+                  <a:srgbClr val="262626"/>
+                </a:solidFill>
+                <a:latin typeface="Arial"/>
+              </a:rPr>
+              <a:t>STT: </a:t>
+            </a:r>
+            <a:r>
+              <a:rPr sz="1100" b="0">
+                <a:solidFill>
+                  <a:srgbClr val="262626"/>
+                </a:solidFill>
+                <a:latin typeface="Arial"/>
+              </a:rPr>
+              <a:t>IndicConformer int8 ONNX (MIT) ×9 languages + whisper.cpp tiny for English.</a:t>
             </a:r>
           </a:p>
           <a:p>
             <a:pPr>
               <a:lnSpc>
-                <a:spcPct val="100000"/>
+                <a:spcPct val="102000"/>
               </a:lnSpc>
               <a:spcAft>
-                <a:spcPts val="600"/>
+                <a:spcPts val="350"/>
               </a:spcAft>
             </a:pPr>
             <a:r>
-              <a:rPr sz="1200" b="0">
+              <a:rPr sz="1100" b="0">
                 <a:solidFill>
                   <a:srgbClr val="262626"/>
                 </a:solidFill>
@@ -7351,35 +7292,35 @@
               <a:t>• </a:t>
             </a:r>
             <a:r>
-              <a:rPr sz="1200" b="1">
-                <a:solidFill>
-                  <a:srgbClr val="262626"/>
-                </a:solidFill>
-                <a:latin typeface="Arial"/>
-              </a:rPr>
-              <a:t>STT: </a:t>
-            </a:r>
-            <a:r>
-              <a:rPr sz="1200" b="0">
-                <a:solidFill>
-                  <a:srgbClr val="262626"/>
-                </a:solidFill>
-                <a:latin typeface="Arial"/>
-              </a:rPr>
-              <a:t>IndicConformer int8 ONNX (MIT) ×9 languages + English; desktop RTF 0.055–0.119 measured.</a:t>
+              <a:rPr sz="1100" b="1">
+                <a:solidFill>
+                  <a:srgbClr val="262626"/>
+                </a:solidFill>
+                <a:latin typeface="Arial"/>
+              </a:rPr>
+              <a:t>TTS: </a:t>
+            </a:r>
+            <a:r>
+              <a:rPr sz="1100" b="0">
+                <a:solidFill>
+                  <a:srgbClr val="262626"/>
+                </a:solidFill>
+                <a:latin typeface="Arial"/>
+              </a:rPr>
+              <a:t>Piper VITS ×6 + AI4Bharat FastPitch+HiFi-GAN ONNX ×4; eSpeak-NG fallback.</a:t>
             </a:r>
           </a:p>
           <a:p>
             <a:pPr>
               <a:lnSpc>
-                <a:spcPct val="100000"/>
+                <a:spcPct val="102000"/>
               </a:lnSpc>
               <a:spcAft>
-                <a:spcPts val="600"/>
+                <a:spcPts val="350"/>
               </a:spcAft>
             </a:pPr>
             <a:r>
-              <a:rPr sz="1200" b="0">
+              <a:rPr sz="1100" b="0">
                 <a:solidFill>
                   <a:srgbClr val="262626"/>
                 </a:solidFill>
@@ -7388,35 +7329,35 @@
               <a:t>• </a:t>
             </a:r>
             <a:r>
-              <a:rPr sz="1200" b="1">
-                <a:solidFill>
-                  <a:srgbClr val="262626"/>
-                </a:solidFill>
-                <a:latin typeface="Arial"/>
-              </a:rPr>
-              <a:t>TTS: </a:t>
-            </a:r>
-            <a:r>
-              <a:rPr sz="1200" b="0">
-                <a:solidFill>
-                  <a:srgbClr val="262626"/>
-                </a:solidFill>
-                <a:latin typeface="Arial"/>
-              </a:rPr>
-              <a:t>Piper VITS ×6 + AI4Bharat FastPitch ONNX ×4, RTF 0.049 measured; eSpeak-NG fallback.</a:t>
+              <a:rPr sz="1100" b="1">
+                <a:solidFill>
+                  <a:srgbClr val="262626"/>
+                </a:solidFill>
+                <a:latin typeface="Arial"/>
+              </a:rPr>
+              <a:t>Silero VAD (~2 MB) </a:t>
+            </a:r>
+            <a:r>
+              <a:rPr sz="1100" b="0">
+                <a:solidFill>
+                  <a:srgbClr val="262626"/>
+                </a:solidFill>
+                <a:latin typeface="Arial"/>
+              </a:rPr>
+              <a:t>sentence chunking · Oboe (AAudio) 16 kHz low-latency audio.</a:t>
             </a:r>
           </a:p>
           <a:p>
             <a:pPr>
               <a:lnSpc>
-                <a:spcPct val="100000"/>
+                <a:spcPct val="102000"/>
               </a:lnSpc>
               <a:spcAft>
-                <a:spcPts val="600"/>
+                <a:spcPts val="350"/>
               </a:spcAft>
             </a:pPr>
             <a:r>
-              <a:rPr sz="1200" b="0">
+              <a:rPr sz="1100" b="0">
                 <a:solidFill>
                   <a:srgbClr val="262626"/>
                 </a:solidFill>
@@ -7425,35 +7366,35 @@
               <a:t>• </a:t>
             </a:r>
             <a:r>
-              <a:rPr sz="1200" b="1">
-                <a:solidFill>
-                  <a:srgbClr val="262626"/>
-                </a:solidFill>
-                <a:latin typeface="Arial"/>
-              </a:rPr>
-              <a:t>Silero VAD (~2 MB) </a:t>
-            </a:r>
-            <a:r>
-              <a:rPr sz="1200" b="0">
-                <a:solidFill>
-                  <a:srgbClr val="262626"/>
-                </a:solidFill>
-                <a:latin typeface="Arial"/>
-              </a:rPr>
-              <a:t>sentence chunking · Oboe (AAudio) 16 kHz low-latency audio.</a:t>
+              <a:rPr sz="1100" b="1">
+                <a:solidFill>
+                  <a:srgbClr val="262626"/>
+                </a:solidFill>
+                <a:latin typeface="Arial"/>
+              </a:rPr>
+              <a:t>Transports: </a:t>
+            </a:r>
+            <a:r>
+              <a:rPr sz="1100" b="0">
+                <a:solidFill>
+                  <a:srgbClr val="262626"/>
+                </a:solidFill>
+                <a:latin typeface="Arial"/>
+              </a:rPr>
+              <a:t>NSD/mDNS + TCP · Bluetooth RFCOMM · ESP32+SX127x LoRa (IN865, 1% duty).</a:t>
             </a:r>
           </a:p>
           <a:p>
             <a:pPr>
               <a:lnSpc>
-                <a:spcPct val="100000"/>
+                <a:spcPct val="102000"/>
               </a:lnSpc>
               <a:spcAft>
-                <a:spcPts val="600"/>
+                <a:spcPts val="350"/>
               </a:spcAft>
             </a:pPr>
             <a:r>
-              <a:rPr sz="1200" b="0">
+              <a:rPr sz="1100" b="0">
                 <a:solidFill>
                   <a:srgbClr val="262626"/>
                 </a:solidFill>
@@ -7462,35 +7403,35 @@
               <a:t>• </a:t>
             </a:r>
             <a:r>
-              <a:rPr sz="1200" b="1">
-                <a:solidFill>
-                  <a:srgbClr val="262626"/>
-                </a:solidFill>
-                <a:latin typeface="Arial"/>
-              </a:rPr>
-              <a:t>Transports: </a:t>
-            </a:r>
-            <a:r>
-              <a:rPr sz="1200" b="0">
-                <a:solidFill>
-                  <a:srgbClr val="262626"/>
-                </a:solidFill>
-                <a:latin typeface="Arial"/>
-              </a:rPr>
-              <a:t>NSD/mDNS + TCP · Bluetooth RFCOMM · ESP32+SX127x LoRa (IN865, 1% duty).</a:t>
+              <a:rPr sz="1100" b="1">
+                <a:solidFill>
+                  <a:srgbClr val="262626"/>
+                </a:solidFill>
+                <a:latin typeface="Arial"/>
+              </a:rPr>
+              <a:t>Protocol: </a:t>
+            </a:r>
+            <a:r>
+              <a:rPr sz="1100" b="0">
+                <a:solidFill>
+                  <a:srgbClr val="262626"/>
+                </a:solidFill>
+                <a:latin typeface="Arial"/>
+              </a:rPr>
+              <a:t>VarnaCode + iTantra Frame [lang · priority · seq · CRC-16] — bearer-agnostic, Kotlin↔Python byte-identical.</a:t>
             </a:r>
           </a:p>
           <a:p>
             <a:pPr>
               <a:lnSpc>
-                <a:spcPct val="100000"/>
+                <a:spcPct val="102000"/>
               </a:lnSpc>
               <a:spcAft>
-                <a:spcPts val="600"/>
+                <a:spcPts val="350"/>
               </a:spcAft>
             </a:pPr>
             <a:r>
-              <a:rPr sz="1200" b="0">
+              <a:rPr sz="1100" b="0">
                 <a:solidFill>
                   <a:srgbClr val="262626"/>
                 </a:solidFill>
@@ -7499,35 +7440,54 @@
               <a:t>• </a:t>
             </a:r>
             <a:r>
-              <a:rPr sz="1200" b="1">
-                <a:solidFill>
-                  <a:srgbClr val="262626"/>
-                </a:solidFill>
-                <a:latin typeface="Arial"/>
-              </a:rPr>
-              <a:t>Protocol: </a:t>
-            </a:r>
-            <a:r>
-              <a:rPr sz="1200" b="0">
-                <a:solidFill>
-                  <a:srgbClr val="262626"/>
-                </a:solidFill>
-                <a:latin typeface="Arial"/>
-              </a:rPr>
-              <a:t>VarnaCode + iTantra Frame [lang·priority·seq·CRC-16] — Kotlin↔Python byte-identical, 143 assertions.</a:t>
+              <a:rPr sz="1100" b="1">
+                <a:solidFill>
+                  <a:srgbClr val="262626"/>
+                </a:solidFill>
+                <a:latin typeface="Arial"/>
+              </a:rPr>
+              <a:t>Compliance: </a:t>
+            </a:r>
+            <a:r>
+              <a:rPr sz="1100" b="0">
+                <a:solidFill>
+                  <a:srgbClr val="262626"/>
+                </a:solidFill>
+                <a:latin typeface="Arial"/>
+              </a:rPr>
+              <a:t>100% open-source (NC/proprietary SDKs excluded) · zero network calls.</a:t>
+            </a:r>
+          </a:p>
+          <a:p>
+            <a:pPr>
+              <a:spcBef>
+                <a:spcPts val="500"/>
+              </a:spcBef>
+              <a:spcAft>
+                <a:spcPts val="300"/>
+              </a:spcAft>
+            </a:pPr>
+            <a:r>
+              <a:rPr sz="1250" b="1">
+                <a:solidFill>
+                  <a:srgbClr val="1F3864"/>
+                </a:solidFill>
+                <a:latin typeface="Arial"/>
+              </a:rPr>
+              <a:t>Methodology</a:t>
             </a:r>
           </a:p>
           <a:p>
             <a:pPr>
               <a:lnSpc>
-                <a:spcPct val="100000"/>
+                <a:spcPct val="102000"/>
               </a:lnSpc>
               <a:spcAft>
-                <a:spcPts val="600"/>
+                <a:spcPts val="350"/>
               </a:spcAft>
             </a:pPr>
             <a:r>
-              <a:rPr sz="1200" b="0">
+              <a:rPr sz="1100" b="0">
                 <a:solidFill>
                   <a:srgbClr val="262626"/>
                 </a:solidFill>
@@ -7536,53 +7496,59 @@
               <a:t>• </a:t>
             </a:r>
             <a:r>
-              <a:rPr sz="1200" b="1">
-                <a:solidFill>
-                  <a:srgbClr val="262626"/>
-                </a:solidFill>
-                <a:latin typeface="Arial"/>
-              </a:rPr>
-              <a:t>Compliance: </a:t>
-            </a:r>
-            <a:r>
-              <a:rPr sz="1200" b="0">
-                <a:solidFill>
-                  <a:srgbClr val="262626"/>
-                </a:solidFill>
-                <a:latin typeface="Arial"/>
-              </a:rPr>
-              <a:t>100% open-source (NC &amp; proprietary SDKs excluded) · zero network calls.</a:t>
+              <a:rPr sz="1100" b="1">
+                <a:solidFill>
+                  <a:srgbClr val="262626"/>
+                </a:solidFill>
+                <a:latin typeface="Arial"/>
+              </a:rPr>
+              <a:t>P0 desktop twin measured first </a:t>
+            </a:r>
+            <a:r>
+              <a:rPr sz="1100" b="0">
+                <a:solidFill>
+                  <a:srgbClr val="262626"/>
+                </a:solidFill>
+                <a:latin typeface="Arial"/>
+              </a:rPr>
+              <a:t>(CER · RTF · compression) → </a:t>
             </a:r>
           </a:p>
           <a:p>
             <a:pPr>
               <a:lnSpc>
-                <a:spcPct val="100000"/>
+                <a:spcPct val="102000"/>
               </a:lnSpc>
-              <a:spcBef>
-                <a:spcPts val="700"/>
-              </a:spcBef>
               <a:spcAft>
-                <a:spcPts val="0"/>
+                <a:spcPts val="350"/>
               </a:spcAft>
             </a:pPr>
             <a:r>
-              <a:rPr sz="1200" b="1">
-                <a:solidFill>
-                  <a:srgbClr val="1F3864"/>
-                </a:solidFill>
-                <a:latin typeface="Arial"/>
-              </a:rPr>
-              <a:t>Methodology: </a:t>
-            </a:r>
-            <a:r>
-              <a:rPr sz="1200" b="0">
-                <a:solidFill>
-                  <a:srgbClr val="262626"/>
-                </a:solidFill>
-                <a:latin typeface="Arial"/>
-              </a:rPr>
-              <a:t>P0 desktop twin measured first (CER/RTF/compression) → P1–P2 Android spine + Hindi loop → P3 ten languages + alerts → P4 Evaluation Mode → P5 LoRa + AES-GCM.</a:t>
+              <a:rPr sz="1100" b="0">
+                <a:solidFill>
+                  <a:srgbClr val="262626"/>
+                </a:solidFill>
+                <a:latin typeface="Arial"/>
+              </a:rPr>
+              <a:t>• </a:t>
+            </a:r>
+            <a:r>
+              <a:rPr sz="1100" b="1">
+                <a:solidFill>
+                  <a:srgbClr val="262626"/>
+                </a:solidFill>
+                <a:latin typeface="Arial"/>
+              </a:rPr>
+              <a:t>P1–P5: </a:t>
+            </a:r>
+            <a:r>
+              <a:rPr sz="1100" b="0">
+                <a:solidFill>
+                  <a:srgbClr val="262626"/>
+                </a:solidFill>
+                <a:latin typeface="Arial"/>
+              </a:rPr>
+              <a:t>Android spine + Hindi loop → 10 languages + alerts → Evaluation Mode → LoRa bridge + AES-GCM.</a:t>
             </a:r>
           </a:p>
         </p:txBody>
@@ -7603,8 +7569,8 @@
         </p:blipFill>
         <p:spPr>
           <a:xfrm>
-            <a:off x="6400800" y="896112"/>
-            <a:ext cx="5760720" cy="2066543"/>
+            <a:off x="5669280" y="1188720"/>
+            <a:ext cx="5989320" cy="3083711"/>
           </a:xfrm>
           <a:prstGeom prst="rect">
             <a:avLst/>
@@ -7613,549 +7579,14 @@
       </p:pic>
       <p:sp>
         <p:nvSpPr>
-          <p:cNvPr id="17412" name="TextBox 17411"/>
-          <p:cNvSpPr txBox="1"/>
+          <p:cNvPr id="17412" name="Rounded Rectangle 17411"/>
+          <p:cNvSpPr/>
           <p:nvPr/>
         </p:nvSpPr>
         <p:spPr>
           <a:xfrm>
-            <a:off x="6547104" y="3072384"/>
-            <a:ext cx="5577840" cy="274320"/>
-          </a:xfrm>
-          <a:prstGeom prst="rect">
-            <a:avLst/>
-          </a:prstGeom>
-          <a:noFill/>
-        </p:spPr>
-        <p:txBody>
-          <a:bodyPr wrap="square">
-            <a:spAutoFit/>
-          </a:bodyPr>
-          <a:lstStyle/>
-          <a:p>
-            <a:pPr algn="ctr">
-              <a:spcAft>
-                <a:spcPts val="400"/>
-              </a:spcAft>
-            </a:pPr>
-            <a:r>
-              <a:rPr sz="1100" b="1">
-                <a:solidFill>
-                  <a:srgbClr val="1F3864"/>
-                </a:solidFill>
-                <a:latin typeface="Arial"/>
-              </a:rPr>
-              <a:t>Proposed Tech Stack</a:t>
-            </a:r>
-          </a:p>
-        </p:txBody>
-      </p:sp>
-      <p:sp>
-        <p:nvSpPr>
-          <p:cNvPr id="17413" name="Rounded Rectangle 17412"/>
-          <p:cNvSpPr/>
-          <p:nvPr/>
-        </p:nvSpPr>
-        <p:spPr>
-          <a:xfrm>
-            <a:off x="6547104" y="3401568"/>
-            <a:ext cx="1316736" cy="640080"/>
-          </a:xfrm>
-          <a:prstGeom prst="roundRect">
-            <a:avLst/>
-          </a:prstGeom>
-          <a:solidFill>
-            <a:srgbClr val="EBF3FA"/>
-          </a:solidFill>
-          <a:ln w="15875">
-            <a:solidFill>
-              <a:srgbClr val="1D6FA8"/>
-            </a:solidFill>
-          </a:ln>
-          <a:effectLst/>
-        </p:spPr>
-        <p:style>
-          <a:lnRef idx="1">
-            <a:schemeClr val="accent1"/>
-          </a:lnRef>
-          <a:fillRef idx="3">
-            <a:schemeClr val="accent1"/>
-          </a:fillRef>
-          <a:effectRef idx="2">
-            <a:schemeClr val="accent1"/>
-          </a:effectRef>
-          <a:fontRef idx="minor">
-            <a:schemeClr val="lt1"/>
-          </a:fontRef>
-        </p:style>
-        <p:txBody>
-          <a:bodyPr rtlCol="0" anchor="ctr" wrap="square" tIns="54864"/>
-          <a:lstStyle/>
-          <a:p>
-            <a:pPr algn="ctr">
-              <a:lnSpc>
-                <a:spcPct val="95000"/>
-              </a:lnSpc>
-              <a:spcAft>
-                <a:spcPts val="0"/>
-              </a:spcAft>
-            </a:pPr>
-            <a:r>
-              <a:rPr sz="1000" b="1">
-                <a:solidFill>
-                  <a:srgbClr val="262626"/>
-                </a:solidFill>
-                <a:latin typeface="Arial"/>
-              </a:rPr>
-              <a:t>Kotlin + Compose</a:t>
-            </a:r>
-          </a:p>
-        </p:txBody>
-      </p:sp>
-      <p:sp>
-        <p:nvSpPr>
-          <p:cNvPr id="17414" name="Rounded Rectangle 17413"/>
-          <p:cNvSpPr/>
-          <p:nvPr/>
-        </p:nvSpPr>
-        <p:spPr>
-          <a:xfrm>
-            <a:off x="7964424" y="3401568"/>
-            <a:ext cx="1316736" cy="640080"/>
-          </a:xfrm>
-          <a:prstGeom prst="roundRect">
-            <a:avLst/>
-          </a:prstGeom>
-          <a:solidFill>
-            <a:srgbClr val="ECF6EC"/>
-          </a:solidFill>
-          <a:ln w="15875">
-            <a:solidFill>
-              <a:srgbClr val="2E7D32"/>
-            </a:solidFill>
-          </a:ln>
-          <a:effectLst/>
-        </p:spPr>
-        <p:style>
-          <a:lnRef idx="1">
-            <a:schemeClr val="accent1"/>
-          </a:lnRef>
-          <a:fillRef idx="3">
-            <a:schemeClr val="accent1"/>
-          </a:fillRef>
-          <a:effectRef idx="2">
-            <a:schemeClr val="accent1"/>
-          </a:effectRef>
-          <a:fontRef idx="minor">
-            <a:schemeClr val="lt1"/>
-          </a:fontRef>
-        </p:style>
-        <p:txBody>
-          <a:bodyPr rtlCol="0" anchor="ctr" wrap="square" tIns="54864"/>
-          <a:lstStyle/>
-          <a:p>
-            <a:pPr algn="ctr">
-              <a:lnSpc>
-                <a:spcPct val="95000"/>
-              </a:lnSpc>
-              <a:spcAft>
-                <a:spcPts val="0"/>
-              </a:spcAft>
-            </a:pPr>
-            <a:r>
-              <a:rPr sz="1000" b="1">
-                <a:solidFill>
-                  <a:srgbClr val="262626"/>
-                </a:solidFill>
-                <a:latin typeface="Arial"/>
-              </a:rPr>
-              <a:t>sherpa-onnx</a:t>
-            </a:r>
-          </a:p>
-        </p:txBody>
-      </p:sp>
-      <p:sp>
-        <p:nvSpPr>
-          <p:cNvPr id="17415" name="Rounded Rectangle 17414"/>
-          <p:cNvSpPr/>
-          <p:nvPr/>
-        </p:nvSpPr>
-        <p:spPr>
-          <a:xfrm>
-            <a:off x="9381744" y="3401568"/>
-            <a:ext cx="1316736" cy="640080"/>
-          </a:xfrm>
-          <a:prstGeom prst="roundRect">
-            <a:avLst/>
-          </a:prstGeom>
-          <a:solidFill>
-            <a:srgbClr val="FDF3EC"/>
-          </a:solidFill>
-          <a:ln w="15875">
-            <a:solidFill>
-              <a:srgbClr val="C55A11"/>
-            </a:solidFill>
-          </a:ln>
-          <a:effectLst/>
-        </p:spPr>
-        <p:style>
-          <a:lnRef idx="1">
-            <a:schemeClr val="accent1"/>
-          </a:lnRef>
-          <a:fillRef idx="3">
-            <a:schemeClr val="accent1"/>
-          </a:fillRef>
-          <a:effectRef idx="2">
-            <a:schemeClr val="accent1"/>
-          </a:effectRef>
-          <a:fontRef idx="minor">
-            <a:schemeClr val="lt1"/>
-          </a:fontRef>
-        </p:style>
-        <p:txBody>
-          <a:bodyPr rtlCol="0" anchor="ctr" wrap="square" tIns="54864"/>
-          <a:lstStyle/>
-          <a:p>
-            <a:pPr algn="ctr">
-              <a:lnSpc>
-                <a:spcPct val="95000"/>
-              </a:lnSpc>
-              <a:spcAft>
-                <a:spcPts val="0"/>
-              </a:spcAft>
-            </a:pPr>
-            <a:r>
-              <a:rPr sz="1000" b="1">
-                <a:solidFill>
-                  <a:srgbClr val="262626"/>
-                </a:solidFill>
-                <a:latin typeface="Arial"/>
-              </a:rPr>
-              <a:t>IndicConformer int8</a:t>
-            </a:r>
-          </a:p>
-        </p:txBody>
-      </p:sp>
-      <p:sp>
-        <p:nvSpPr>
-          <p:cNvPr id="17416" name="Rounded Rectangle 17415"/>
-          <p:cNvSpPr/>
-          <p:nvPr/>
-        </p:nvSpPr>
-        <p:spPr>
-          <a:xfrm>
-            <a:off x="10799064" y="3401568"/>
-            <a:ext cx="1316736" cy="640080"/>
-          </a:xfrm>
-          <a:prstGeom prst="roundRect">
-            <a:avLst/>
-          </a:prstGeom>
-          <a:solidFill>
-            <a:srgbClr val="EBF3FA"/>
-          </a:solidFill>
-          <a:ln w="15875">
-            <a:solidFill>
-              <a:srgbClr val="1D6FA8"/>
-            </a:solidFill>
-          </a:ln>
-          <a:effectLst/>
-        </p:spPr>
-        <p:style>
-          <a:lnRef idx="1">
-            <a:schemeClr val="accent1"/>
-          </a:lnRef>
-          <a:fillRef idx="3">
-            <a:schemeClr val="accent1"/>
-          </a:fillRef>
-          <a:effectRef idx="2">
-            <a:schemeClr val="accent1"/>
-          </a:effectRef>
-          <a:fontRef idx="minor">
-            <a:schemeClr val="lt1"/>
-          </a:fontRef>
-        </p:style>
-        <p:txBody>
-          <a:bodyPr rtlCol="0" anchor="ctr" wrap="square" tIns="54864"/>
-          <a:lstStyle/>
-          <a:p>
-            <a:pPr algn="ctr">
-              <a:lnSpc>
-                <a:spcPct val="95000"/>
-              </a:lnSpc>
-              <a:spcAft>
-                <a:spcPts val="0"/>
-              </a:spcAft>
-            </a:pPr>
-            <a:r>
-              <a:rPr sz="1000" b="1">
-                <a:solidFill>
-                  <a:srgbClr val="262626"/>
-                </a:solidFill>
-                <a:latin typeface="Arial"/>
-              </a:rPr>
-              <a:t>Piper / FastPitch</a:t>
-            </a:r>
-          </a:p>
-        </p:txBody>
-      </p:sp>
-      <p:sp>
-        <p:nvSpPr>
-          <p:cNvPr id="17417" name="Rounded Rectangle 17416"/>
-          <p:cNvSpPr/>
-          <p:nvPr/>
-        </p:nvSpPr>
-        <p:spPr>
-          <a:xfrm>
-            <a:off x="6547104" y="4206240"/>
-            <a:ext cx="1316736" cy="640080"/>
-          </a:xfrm>
-          <a:prstGeom prst="roundRect">
-            <a:avLst/>
-          </a:prstGeom>
-          <a:solidFill>
-            <a:srgbClr val="ECF6EC"/>
-          </a:solidFill>
-          <a:ln w="15875">
-            <a:solidFill>
-              <a:srgbClr val="2E7D32"/>
-            </a:solidFill>
-          </a:ln>
-          <a:effectLst/>
-        </p:spPr>
-        <p:style>
-          <a:lnRef idx="1">
-            <a:schemeClr val="accent1"/>
-          </a:lnRef>
-          <a:fillRef idx="3">
-            <a:schemeClr val="accent1"/>
-          </a:fillRef>
-          <a:effectRef idx="2">
-            <a:schemeClr val="accent1"/>
-          </a:effectRef>
-          <a:fontRef idx="minor">
-            <a:schemeClr val="lt1"/>
-          </a:fontRef>
-        </p:style>
-        <p:txBody>
-          <a:bodyPr rtlCol="0" anchor="ctr" wrap="square" tIns="54864"/>
-          <a:lstStyle/>
-          <a:p>
-            <a:pPr algn="ctr">
-              <a:lnSpc>
-                <a:spcPct val="95000"/>
-              </a:lnSpc>
-              <a:spcAft>
-                <a:spcPts val="0"/>
-              </a:spcAft>
-            </a:pPr>
-            <a:r>
-              <a:rPr sz="1000" b="1">
-                <a:solidFill>
-                  <a:srgbClr val="262626"/>
-                </a:solidFill>
-                <a:latin typeface="Arial"/>
-              </a:rPr>
-              <a:t>Silero VAD</a:t>
-            </a:r>
-          </a:p>
-        </p:txBody>
-      </p:sp>
-      <p:sp>
-        <p:nvSpPr>
-          <p:cNvPr id="17418" name="Rounded Rectangle 17417"/>
-          <p:cNvSpPr/>
-          <p:nvPr/>
-        </p:nvSpPr>
-        <p:spPr>
-          <a:xfrm>
-            <a:off x="7964424" y="4206240"/>
-            <a:ext cx="1316736" cy="640080"/>
-          </a:xfrm>
-          <a:prstGeom prst="roundRect">
-            <a:avLst/>
-          </a:prstGeom>
-          <a:solidFill>
-            <a:srgbClr val="FDF3EC"/>
-          </a:solidFill>
-          <a:ln w="15875">
-            <a:solidFill>
-              <a:srgbClr val="C55A11"/>
-            </a:solidFill>
-          </a:ln>
-          <a:effectLst/>
-        </p:spPr>
-        <p:style>
-          <a:lnRef idx="1">
-            <a:schemeClr val="accent1"/>
-          </a:lnRef>
-          <a:fillRef idx="3">
-            <a:schemeClr val="accent1"/>
-          </a:fillRef>
-          <a:effectRef idx="2">
-            <a:schemeClr val="accent1"/>
-          </a:effectRef>
-          <a:fontRef idx="minor">
-            <a:schemeClr val="lt1"/>
-          </a:fontRef>
-        </p:style>
-        <p:txBody>
-          <a:bodyPr rtlCol="0" anchor="ctr" wrap="square" tIns="54864"/>
-          <a:lstStyle/>
-          <a:p>
-            <a:pPr algn="ctr">
-              <a:lnSpc>
-                <a:spcPct val="95000"/>
-              </a:lnSpc>
-              <a:spcAft>
-                <a:spcPts val="0"/>
-              </a:spcAft>
-            </a:pPr>
-            <a:r>
-              <a:rPr sz="1000" b="1">
-                <a:solidFill>
-                  <a:srgbClr val="262626"/>
-                </a:solidFill>
-                <a:latin typeface="Arial"/>
-              </a:rPr>
-              <a:t>Oboe audio</a:t>
-            </a:r>
-          </a:p>
-        </p:txBody>
-      </p:sp>
-      <p:sp>
-        <p:nvSpPr>
-          <p:cNvPr id="17419" name="Rounded Rectangle 17418"/>
-          <p:cNvSpPr/>
-          <p:nvPr/>
-        </p:nvSpPr>
-        <p:spPr>
-          <a:xfrm>
-            <a:off x="9381744" y="4206240"/>
-            <a:ext cx="1316736" cy="640080"/>
-          </a:xfrm>
-          <a:prstGeom prst="roundRect">
-            <a:avLst/>
-          </a:prstGeom>
-          <a:solidFill>
-            <a:srgbClr val="EBF3FA"/>
-          </a:solidFill>
-          <a:ln w="15875">
-            <a:solidFill>
-              <a:srgbClr val="1D6FA8"/>
-            </a:solidFill>
-          </a:ln>
-          <a:effectLst/>
-        </p:spPr>
-        <p:style>
-          <a:lnRef idx="1">
-            <a:schemeClr val="accent1"/>
-          </a:lnRef>
-          <a:fillRef idx="3">
-            <a:schemeClr val="accent1"/>
-          </a:fillRef>
-          <a:effectRef idx="2">
-            <a:schemeClr val="accent1"/>
-          </a:effectRef>
-          <a:fontRef idx="minor">
-            <a:schemeClr val="lt1"/>
-          </a:fontRef>
-        </p:style>
-        <p:txBody>
-          <a:bodyPr rtlCol="0" anchor="ctr" wrap="square" tIns="54864"/>
-          <a:lstStyle/>
-          <a:p>
-            <a:pPr algn="ctr">
-              <a:lnSpc>
-                <a:spcPct val="95000"/>
-              </a:lnSpc>
-              <a:spcAft>
-                <a:spcPts val="0"/>
-              </a:spcAft>
-            </a:pPr>
-            <a:r>
-              <a:rPr sz="1000" b="1">
-                <a:solidFill>
-                  <a:srgbClr val="262626"/>
-                </a:solidFill>
-                <a:latin typeface="Arial"/>
-              </a:rPr>
-              <a:t>NSD + BT RFCOMM</a:t>
-            </a:r>
-          </a:p>
-        </p:txBody>
-      </p:sp>
-      <p:sp>
-        <p:nvSpPr>
-          <p:cNvPr id="17420" name="Rounded Rectangle 17419"/>
-          <p:cNvSpPr/>
-          <p:nvPr/>
-        </p:nvSpPr>
-        <p:spPr>
-          <a:xfrm>
-            <a:off x="10799064" y="4206240"/>
-            <a:ext cx="1316736" cy="640080"/>
-          </a:xfrm>
-          <a:prstGeom prst="roundRect">
-            <a:avLst/>
-          </a:prstGeom>
-          <a:solidFill>
-            <a:srgbClr val="ECF6EC"/>
-          </a:solidFill>
-          <a:ln w="15875">
-            <a:solidFill>
-              <a:srgbClr val="2E7D32"/>
-            </a:solidFill>
-          </a:ln>
-          <a:effectLst/>
-        </p:spPr>
-        <p:style>
-          <a:lnRef idx="1">
-            <a:schemeClr val="accent1"/>
-          </a:lnRef>
-          <a:fillRef idx="3">
-            <a:schemeClr val="accent1"/>
-          </a:fillRef>
-          <a:effectRef idx="2">
-            <a:schemeClr val="accent1"/>
-          </a:effectRef>
-          <a:fontRef idx="minor">
-            <a:schemeClr val="lt1"/>
-          </a:fontRef>
-        </p:style>
-        <p:txBody>
-          <a:bodyPr rtlCol="0" anchor="ctr" wrap="square" tIns="54864"/>
-          <a:lstStyle/>
-          <a:p>
-            <a:pPr algn="ctr">
-              <a:lnSpc>
-                <a:spcPct val="95000"/>
-              </a:lnSpc>
-              <a:spcAft>
-                <a:spcPts val="0"/>
-              </a:spcAft>
-            </a:pPr>
-            <a:r>
-              <a:rPr sz="1000" b="1">
-                <a:solidFill>
-                  <a:srgbClr val="262626"/>
-                </a:solidFill>
-                <a:latin typeface="Arial"/>
-              </a:rPr>
-              <a:t>ESP32 LoRa · IN865</a:t>
-            </a:r>
-          </a:p>
-        </p:txBody>
-      </p:sp>
-      <p:sp>
-        <p:nvSpPr>
-          <p:cNvPr id="17421" name="Rounded Rectangle 17420"/>
-          <p:cNvSpPr/>
-          <p:nvPr/>
-        </p:nvSpPr>
-        <p:spPr>
-          <a:xfrm>
-            <a:off x="6547104" y="4956048"/>
-            <a:ext cx="5577840" cy="1188720"/>
+            <a:off x="5669280" y="4480560"/>
+            <a:ext cx="5989320" cy="1417320"/>
           </a:xfrm>
           <a:prstGeom prst="roundRect">
             <a:avLst/>
@@ -8185,8 +7616,24 @@
           </a:fontRef>
         </p:style>
         <p:txBody>
-          <a:bodyPr rtlCol="0" anchor="ctr" wrap="square" tIns="54864"/>
+          <a:bodyPr rtlCol="0" anchor="ctr" wrap="square" bIns="36576"/>
           <a:lstStyle/>
+          <a:p>
+            <a:pPr algn="ctr">
+              <a:spcAft>
+                <a:spcPts val="400"/>
+              </a:spcAft>
+            </a:pPr>
+            <a:r>
+              <a:rPr sz="1250" b="1">
+                <a:solidFill>
+                  <a:srgbClr val="1F3864"/>
+                </a:solidFill>
+                <a:latin typeface="Arial"/>
+              </a:rPr>
+              <a:t>Measured, not estimated — desktop CPU, real models</a:t>
+            </a:r>
+          </a:p>
           <a:p>
             <a:pPr algn="ctr">
               <a:spcAft>
@@ -8196,27 +7643,27 @@
             <a:r>
               <a:rPr sz="1100" b="1">
                 <a:solidFill>
-                  <a:srgbClr val="1F3864"/>
-                </a:solidFill>
-                <a:latin typeface="Arial"/>
-              </a:rPr>
-              <a:t>Measured tonight — desktop CPU, real models</a:t>
+                  <a:srgbClr val="262626"/>
+                </a:solidFill>
+                <a:latin typeface="Arial"/>
+              </a:rPr>
+              <a:t>STT RTF 0.055–0.119 · TTS RTF 0.049 · Hindi round-trip CER 1.6% / WER 7.1%</a:t>
             </a:r>
           </a:p>
           <a:p>
             <a:pPr algn="ctr">
               <a:spcAft>
-                <a:spcPts val="200"/>
+                <a:spcPts val="300"/>
               </a:spcAft>
             </a:pPr>
             <a:r>
-              <a:rPr sz="1100" b="1">
-                <a:solidFill>
-                  <a:srgbClr val="262626"/>
-                </a:solidFill>
-                <a:latin typeface="Arial"/>
-              </a:rPr>
-              <a:t>STT RTF 0.055–0.119 · TTS RTF 0.049 · Hindi round-trip CER 1.6% / WER 7.1%</a:t>
+              <a:rPr sz="1050" b="0">
+                <a:solidFill>
+                  <a:srgbClr val="262626"/>
+                </a:solidFill>
+                <a:latin typeface="Arial"/>
+              </a:rPr>
+              <a:t>VarnaCode v1: 4.45–5.36 bits/char across all 10 languages · 154 protocol assertions green</a:t>
             </a:r>
           </a:p>
           <a:p>
@@ -8226,13 +7673,13 @@
               </a:spcAft>
             </a:pPr>
             <a:r>
-              <a:rPr sz="1000" b="0">
-                <a:solidFill>
-                  <a:srgbClr val="262626"/>
-                </a:solidFill>
-                <a:latin typeface="Arial"/>
-              </a:rPr>
-              <a:t>VarnaCode 4.6–5.3 bits/char (hi·bn·ta·te·en) · 143 protocol assertions · Kotlin↔Python byte-identical</a:t>
+              <a:rPr sz="1050" b="0">
+                <a:solidFill>
+                  <a:srgbClr val="262626"/>
+                </a:solidFill>
+                <a:latin typeface="Arial"/>
+              </a:rPr>
+              <a:t>Kotlin ↔ Python wire-compatible · Android APK builds &amp; tests green</a:t>
             </a:r>
           </a:p>
         </p:txBody>
@@ -8621,8 +8068,8 @@
         </p:nvSpPr>
         <p:spPr>
           <a:xfrm>
-            <a:off x="146304" y="969264"/>
-            <a:ext cx="7863840" cy="877824"/>
+            <a:off x="320040" y="1143000"/>
+            <a:ext cx="7543800" cy="1417320"/>
           </a:xfrm>
           <a:prstGeom prst="rect">
             <a:avLst/>
@@ -8640,11 +8087,11 @@
                 <a:spcPct val="100000"/>
               </a:lnSpc>
               <a:spcAft>
-                <a:spcPts val="100"/>
+                <a:spcPts val="250"/>
               </a:spcAft>
             </a:pPr>
             <a:r>
-              <a:rPr sz="1300" b="1">
+              <a:rPr sz="1400" b="1">
                 <a:solidFill>
                   <a:srgbClr val="1F3864"/>
                 </a:solidFill>
@@ -8656,47 +8103,57 @@
           <a:p>
             <a:pPr>
               <a:lnSpc>
-                <a:spcPct val="100000"/>
+                <a:spcPct val="105000"/>
+              </a:lnSpc>
+              <a:spcAft>
+                <a:spcPts val="250"/>
+              </a:spcAft>
+            </a:pPr>
+            <a:r>
+              <a:rPr sz="1200" b="1">
+                <a:solidFill>
+                  <a:srgbClr val="262626"/>
+                </a:solidFill>
+                <a:latin typeface="Arial"/>
+              </a:rPr>
+              <a:t>Problem: </a:t>
+            </a:r>
+            <a:r>
+              <a:rPr sz="1200" b="0">
+                <a:solidFill>
+                  <a:srgbClr val="262626"/>
+                </a:solidFill>
+                <a:latin typeface="Arial"/>
+              </a:rPr>
+              <a:t>desktop/ARM-proxy RTF only; a budget phone may run tighter.</a:t>
+            </a:r>
+          </a:p>
+          <a:p>
+            <a:pPr>
+              <a:lnSpc>
+                <a:spcPct val="105000"/>
               </a:lnSpc>
               <a:spcAft>
                 <a:spcPts val="0"/>
               </a:spcAft>
             </a:pPr>
             <a:r>
-              <a:rPr sz="1100" b="1">
-                <a:solidFill>
-                  <a:srgbClr val="262626"/>
-                </a:solidFill>
-                <a:latin typeface="Arial"/>
-              </a:rPr>
-              <a:t>Problem: </a:t>
-            </a:r>
-            <a:r>
-              <a:rPr sz="1100" b="0">
-                <a:solidFill>
-                  <a:srgbClr val="262626"/>
-                </a:solidFill>
-                <a:latin typeface="Arial"/>
-              </a:rPr>
-              <a:t>phone RTF unproven; figures are desktop/ARM-proxy.</a:t>
-            </a:r>
-            <a:r>
-              <a:rPr sz="1100" b="1">
-                <a:solidFill>
-                  <a:srgbClr val="C55A11"/>
-                </a:solidFill>
-                <a:latin typeface="Arial"/>
-              </a:rPr>
-              <a:t>   Approach: </a:t>
-            </a:r>
-            <a:r>
-              <a:rPr sz="1100" b="0">
-                <a:solidFill>
-                  <a:srgbClr val="262626"/>
-                </a:solidFill>
-                <a:latin typeface="Arial"/>
-              </a:rPr>
-              <a:t>P0 measured desktop RTF 0.049–0.119 (8–20× real-time headroom); int8 ladder + smaller voices if a budget phone runs tight.</a:t>
+              <a:rPr sz="1200" b="1">
+                <a:solidFill>
+                  <a:srgbClr val="1F3864"/>
+                </a:solidFill>
+                <a:latin typeface="Arial"/>
+              </a:rPr>
+              <a:t>Approach: </a:t>
+            </a:r>
+            <a:r>
+              <a:rPr sz="1200" b="0">
+                <a:solidFill>
+                  <a:srgbClr val="262626"/>
+                </a:solidFill>
+                <a:latin typeface="Arial"/>
+              </a:rPr>
+              <a:t>P0 measured RTF 0.049–0.119 (8–20× real-time headroom); int8 ladder + smaller voices + streaming-decode overlap if a budget phone runs tight. Edge Conformers already hit RTF 0.19.</a:t>
             </a:r>
           </a:p>
         </p:txBody>
@@ -8709,8 +8166,8 @@
         </p:nvSpPr>
         <p:spPr>
           <a:xfrm>
-            <a:off x="146304" y="1865376"/>
-            <a:ext cx="7863840" cy="877824"/>
+            <a:off x="320040" y="2624328"/>
+            <a:ext cx="7543800" cy="1417320"/>
           </a:xfrm>
           <a:prstGeom prst="rect">
             <a:avLst/>
@@ -8728,11 +8185,11 @@
                 <a:spcPct val="100000"/>
               </a:lnSpc>
               <a:spcAft>
-                <a:spcPts val="100"/>
+                <a:spcPts val="250"/>
               </a:spcAft>
             </a:pPr>
             <a:r>
-              <a:rPr sz="1300" b="1">
+              <a:rPr sz="1400" b="1">
                 <a:solidFill>
                   <a:srgbClr val="1F3864"/>
                 </a:solidFill>
@@ -8744,47 +8201,57 @@
           <a:p>
             <a:pPr>
               <a:lnSpc>
-                <a:spcPct val="100000"/>
+                <a:spcPct val="105000"/>
+              </a:lnSpc>
+              <a:spcAft>
+                <a:spcPts val="250"/>
+              </a:spcAft>
+            </a:pPr>
+            <a:r>
+              <a:rPr sz="1200" b="1">
+                <a:solidFill>
+                  <a:srgbClr val="262626"/>
+                </a:solidFill>
+                <a:latin typeface="Arial"/>
+              </a:rPr>
+              <a:t>Problem: </a:t>
+            </a:r>
+            <a:r>
+              <a:rPr sz="1200" b="0">
+                <a:solidFill>
+                  <a:srgbClr val="262626"/>
+                </a:solidFill>
+                <a:latin typeface="Arial"/>
+              </a:rPr>
+              <a:t>sherpa-onnx IndicConformer wrappers are community-made, not official k2-fsa artifacts.</a:t>
+            </a:r>
+          </a:p>
+          <a:p>
+            <a:pPr>
+              <a:lnSpc>
+                <a:spcPct val="105000"/>
               </a:lnSpc>
               <a:spcAft>
                 <a:spcPts val="0"/>
               </a:spcAft>
             </a:pPr>
             <a:r>
-              <a:rPr sz="1100" b="1">
-                <a:solidFill>
-                  <a:srgbClr val="262626"/>
-                </a:solidFill>
-                <a:latin typeface="Arial"/>
-              </a:rPr>
-              <a:t>Problem: </a:t>
-            </a:r>
-            <a:r>
-              <a:rPr sz="1100" b="0">
-                <a:solidFill>
-                  <a:srgbClr val="262626"/>
-                </a:solidFill>
-                <a:latin typeface="Arial"/>
-              </a:rPr>
-              <a:t>sherpa-onnx IndicConformer wrappers are community-made.</a:t>
-            </a:r>
-            <a:r>
-              <a:rPr sz="1100" b="1">
-                <a:solidFill>
-                  <a:srgbClr val="C55A11"/>
-                </a:solidFill>
-                <a:latin typeface="Arial"/>
-              </a:rPr>
-              <a:t>   Approach: </a:t>
-            </a:r>
-            <a:r>
-              <a:rPr sz="1100" b="0">
-                <a:solidFill>
-                  <a:srgbClr val="262626"/>
-                </a:solidFill>
-                <a:latin typeface="Arial"/>
-              </a:rPr>
-              <a:t>Per-language QA budgeted; hard fallback = ONNX Runtime Mobile on AI4Bharat’s official int8 export.</a:t>
+              <a:rPr sz="1200" b="1">
+                <a:solidFill>
+                  <a:srgbClr val="1F3864"/>
+                </a:solidFill>
+                <a:latin typeface="Arial"/>
+              </a:rPr>
+              <a:t>Approach: </a:t>
+            </a:r>
+            <a:r>
+              <a:rPr sz="1200" b="0">
+                <a:solidFill>
+                  <a:srgbClr val="262626"/>
+                </a:solidFill>
+                <a:latin typeface="Arial"/>
+              </a:rPr>
+              <a:t>Per-language QA budgeted; hard fallback = direct ONNX Runtime Mobile on AI4Bharat’s official int8 export — more glue, zero conversion risk.</a:t>
             </a:r>
           </a:p>
         </p:txBody>
@@ -8797,8 +8264,8 @@
         </p:nvSpPr>
         <p:spPr>
           <a:xfrm>
-            <a:off x="146304" y="2761488"/>
-            <a:ext cx="7863840" cy="877824"/>
+            <a:off x="320040" y="4105656"/>
+            <a:ext cx="7543800" cy="1417320"/>
           </a:xfrm>
           <a:prstGeom prst="rect">
             <a:avLst/>
@@ -8816,63 +8283,73 @@
                 <a:spcPct val="100000"/>
               </a:lnSpc>
               <a:spcAft>
-                <a:spcPts val="100"/>
+                <a:spcPts val="250"/>
               </a:spcAft>
             </a:pPr>
             <a:r>
-              <a:rPr sz="1300" b="1">
+              <a:rPr sz="1400" b="1">
                 <a:solidFill>
                   <a:srgbClr val="1F3864"/>
                 </a:solidFill>
                 <a:latin typeface="Arial"/>
               </a:rPr>
-              <a:t>3. TTS export for 4 languages</a:t>
+              <a:t>3. STT errors become spoken misinformation</a:t>
             </a:r>
           </a:p>
           <a:p>
             <a:pPr>
               <a:lnSpc>
-                <a:spcPct val="100000"/>
+                <a:spcPct val="105000"/>
+              </a:lnSpc>
+              <a:spcAft>
+                <a:spcPts val="250"/>
+              </a:spcAft>
+            </a:pPr>
+            <a:r>
+              <a:rPr sz="1200" b="1">
+                <a:solidFill>
+                  <a:srgbClr val="262626"/>
+                </a:solidFill>
+                <a:latin typeface="Arial"/>
+              </a:rPr>
+              <a:t>Problem: </a:t>
+            </a:r>
+            <a:r>
+              <a:rPr sz="1200" b="0">
+                <a:solidFill>
+                  <a:srgbClr val="262626"/>
+                </a:solidFill>
+                <a:latin typeface="Arial"/>
+              </a:rPr>
+              <a:t>a mis-recognition would be confidently re-spoken at the far end.</a:t>
+            </a:r>
+          </a:p>
+          <a:p>
+            <a:pPr>
+              <a:lnSpc>
+                <a:spcPct val="105000"/>
               </a:lnSpc>
               <a:spcAft>
                 <a:spcPts val="0"/>
               </a:spcAft>
             </a:pPr>
             <a:r>
-              <a:rPr sz="1100" b="1">
-                <a:solidFill>
-                  <a:srgbClr val="262626"/>
-                </a:solidFill>
-                <a:latin typeface="Arial"/>
-              </a:rPr>
-              <a:t>Problem: </a:t>
-            </a:r>
-            <a:r>
-              <a:rPr sz="1100" b="0">
-                <a:solidFill>
-                  <a:srgbClr val="262626"/>
-                </a:solidFill>
-                <a:latin typeface="Arial"/>
-              </a:rPr>
-              <a:t>Gujarati, Kannada, Tamil, Odia lack ready ONNX voices.</a:t>
-            </a:r>
-            <a:r>
-              <a:rPr sz="1100" b="1">
-                <a:solidFill>
-                  <a:srgbClr val="C55A11"/>
-                </a:solidFill>
-                <a:latin typeface="Arial"/>
-              </a:rPr>
-              <a:t>   Approach: </a:t>
-            </a:r>
-            <a:r>
-              <a:rPr sz="1100" b="0">
-                <a:solidFill>
-                  <a:srgbClr val="262626"/>
-                </a:solidFill>
-                <a:latin typeface="Arial"/>
-              </a:rPr>
-              <a:t>Same FastPitch→ONNX recipe as NVIDIA Riva; scoped to 4; eSpeak-NG keeps every language audible meanwhile.</a:t>
+              <a:rPr sz="1200" b="1">
+                <a:solidFill>
+                  <a:srgbClr val="1F3864"/>
+                </a:solidFill>
+                <a:latin typeface="Arial"/>
+              </a:rPr>
+              <a:t>Approach: </a:t>
+            </a:r>
+            <a:r>
+              <a:rPr sz="1200" b="0">
+                <a:solidFill>
+                  <a:srgbClr val="262626"/>
+                </a:solidFill>
+                <a:latin typeface="Arial"/>
+              </a:rPr>
+              <a:t>Confidence gate (“repeat that?”), transcript shown on both screens, and a pronunciation lexicon for the highest-stakes alert content.</a:t>
             </a:r>
           </a:p>
         </p:txBody>
@@ -8885,8 +8362,8 @@
         </p:nvSpPr>
         <p:spPr>
           <a:xfrm>
-            <a:off x="146304" y="3657600"/>
-            <a:ext cx="7863840" cy="877824"/>
+            <a:off x="320040" y="5623560"/>
+            <a:ext cx="7543800" cy="640080"/>
           </a:xfrm>
           <a:prstGeom prst="rect">
             <a:avLst/>
@@ -8901,249 +8378,36 @@
           <a:p>
             <a:pPr>
               <a:lnSpc>
-                <a:spcPct val="100000"/>
+                <a:spcPct val="105000"/>
               </a:lnSpc>
               <a:spcAft>
-                <a:spcPts val="100"/>
+                <a:spcPts val="400"/>
               </a:spcAft>
             </a:pPr>
             <a:r>
-              <a:rPr sz="1300" b="1">
+              <a:rPr sz="1050" b="1">
                 <a:solidFill>
                   <a:srgbClr val="1F3864"/>
                 </a:solidFill>
                 <a:latin typeface="Arial"/>
               </a:rPr>
-              <a:t>4. Wi-Fi Direct is OEM-flaky</a:t>
-            </a:r>
-          </a:p>
-          <a:p>
-            <a:pPr>
-              <a:lnSpc>
-                <a:spcPct val="100000"/>
-              </a:lnSpc>
-              <a:spcAft>
-                <a:spcPts val="0"/>
-              </a:spcAft>
-            </a:pPr>
-            <a:r>
-              <a:rPr sz="1100" b="1">
-                <a:solidFill>
-                  <a:srgbClr val="262626"/>
-                </a:solidFill>
-                <a:latin typeface="Arial"/>
-              </a:rPr>
-              <a:t>Problem: </a:t>
-            </a:r>
-            <a:r>
-              <a:rPr sz="1100" b="0">
-                <a:solidFill>
-                  <a:srgbClr val="262626"/>
-                </a:solidFill>
-                <a:latin typeface="Arial"/>
-              </a:rPr>
-              <a:t>pairing silently fails on some vendor skins.</a:t>
-            </a:r>
-            <a:r>
-              <a:rPr sz="1100" b="1">
-                <a:solidFill>
-                  <a:srgbClr val="C55A11"/>
-                </a:solidFill>
-                <a:latin typeface="Arial"/>
-              </a:rPr>
-              <a:t>   Approach: </a:t>
-            </a:r>
-            <a:r>
-              <a:rPr sz="1100" b="0">
-                <a:solidFill>
-                  <a:srgbClr val="262626"/>
-                </a:solidFill>
-                <a:latin typeface="Arial"/>
-              </a:rPr>
-              <a:t>Not on the critical path: hotspot + NSD + TCP default, Bluetooth RFCOMM backup, Wi-Fi Direct = stretch.</a:t>
-            </a:r>
-          </a:p>
-        </p:txBody>
-      </p:sp>
-      <p:sp>
-        <p:nvSpPr>
-          <p:cNvPr id="17414" name="TextBox 17413"/>
-          <p:cNvSpPr txBox="1"/>
-          <p:nvPr/>
-        </p:nvSpPr>
-        <p:spPr>
-          <a:xfrm>
-            <a:off x="146304" y="4553712"/>
-            <a:ext cx="7863840" cy="877824"/>
-          </a:xfrm>
-          <a:prstGeom prst="rect">
-            <a:avLst/>
-          </a:prstGeom>
-          <a:noFill/>
-        </p:spPr>
-        <p:txBody>
-          <a:bodyPr wrap="square">
-            <a:spAutoFit/>
-          </a:bodyPr>
-          <a:lstStyle/>
-          <a:p>
-            <a:pPr>
-              <a:lnSpc>
-                <a:spcPct val="100000"/>
-              </a:lnSpc>
-              <a:spcAft>
-                <a:spcPts val="100"/>
-              </a:spcAft>
-            </a:pPr>
-            <a:r>
-              <a:rPr sz="1300" b="1">
-                <a:solidFill>
-                  <a:srgbClr val="1F3864"/>
-                </a:solidFill>
-                <a:latin typeface="Arial"/>
-              </a:rPr>
-              <a:t>5. Android background-audio policy</a:t>
-            </a:r>
-          </a:p>
-          <a:p>
-            <a:pPr>
-              <a:lnSpc>
-                <a:spcPct val="100000"/>
-              </a:lnSpc>
-              <a:spcAft>
-                <a:spcPts val="0"/>
-              </a:spcAft>
-            </a:pPr>
-            <a:r>
-              <a:rPr sz="1100" b="1">
-                <a:solidFill>
-                  <a:srgbClr val="262626"/>
-                </a:solidFill>
-                <a:latin typeface="Arial"/>
-              </a:rPr>
-              <a:t>Problem: </a:t>
-            </a:r>
-            <a:r>
-              <a:rPr sz="1100" b="0">
-                <a:solidFill>
-                  <a:srgbClr val="262626"/>
-                </a:solidFill>
-                <a:latin typeface="Arial"/>
-              </a:rPr>
-              <a:t>where stale sample apps die (fg-service types, focus).</a:t>
-            </a:r>
-            <a:r>
-              <a:rPr sz="1100" b="1">
-                <a:solidFill>
-                  <a:srgbClr val="C55A11"/>
-                </a:solidFill>
-                <a:latin typeface="Arial"/>
-              </a:rPr>
-              <a:t>   Approach: </a:t>
-            </a:r>
-            <a:r>
-              <a:rPr sz="1100" b="0">
-                <a:solidFill>
-                  <a:srgbClr val="262626"/>
-                </a:solidFill>
-                <a:latin typeface="Arial"/>
-              </a:rPr>
-              <a:t>Built fresh and first: fg service + audio focus already in the P1 spine — compiling, tested.</a:t>
-            </a:r>
-          </a:p>
-        </p:txBody>
-      </p:sp>
-      <p:sp>
-        <p:nvSpPr>
-          <p:cNvPr id="17415" name="TextBox 17414"/>
-          <p:cNvSpPr txBox="1"/>
-          <p:nvPr/>
-        </p:nvSpPr>
-        <p:spPr>
-          <a:xfrm>
-            <a:off x="146304" y="5449824"/>
-            <a:ext cx="7863840" cy="877824"/>
-          </a:xfrm>
-          <a:prstGeom prst="rect">
-            <a:avLst/>
-          </a:prstGeom>
-          <a:noFill/>
-        </p:spPr>
-        <p:txBody>
-          <a:bodyPr wrap="square">
-            <a:spAutoFit/>
-          </a:bodyPr>
-          <a:lstStyle/>
-          <a:p>
-            <a:pPr>
-              <a:lnSpc>
-                <a:spcPct val="100000"/>
-              </a:lnSpc>
-              <a:spcAft>
-                <a:spcPts val="100"/>
-              </a:spcAft>
-            </a:pPr>
-            <a:r>
-              <a:rPr sz="1300" b="1">
-                <a:solidFill>
-                  <a:srgbClr val="1F3864"/>
-                </a:solidFill>
-                <a:latin typeface="Arial"/>
-              </a:rPr>
-              <a:t>6. STT errors become spoken misinformation</a:t>
-            </a:r>
-          </a:p>
-          <a:p>
-            <a:pPr>
-              <a:lnSpc>
-                <a:spcPct val="100000"/>
-              </a:lnSpc>
-              <a:spcAft>
-                <a:spcPts val="0"/>
-              </a:spcAft>
-            </a:pPr>
-            <a:r>
-              <a:rPr sz="1100" b="1">
-                <a:solidFill>
-                  <a:srgbClr val="262626"/>
-                </a:solidFill>
-                <a:latin typeface="Arial"/>
-              </a:rPr>
-              <a:t>Problem: </a:t>
-            </a:r>
-            <a:r>
-              <a:rPr sz="1100" b="0">
-                <a:solidFill>
-                  <a:srgbClr val="262626"/>
-                </a:solidFill>
-                <a:latin typeface="Arial"/>
-              </a:rPr>
-              <a:t>a mis-recognition would be confidently re-spoken.</a:t>
-            </a:r>
-            <a:r>
-              <a:rPr sz="1100" b="1">
-                <a:solidFill>
-                  <a:srgbClr val="C55A11"/>
-                </a:solidFill>
-                <a:latin typeface="Arial"/>
-              </a:rPr>
-              <a:t>   Approach: </a:t>
-            </a:r>
-            <a:r>
-              <a:rPr sz="1100" b="0">
-                <a:solidFill>
-                  <a:srgbClr val="262626"/>
-                </a:solidFill>
-                <a:latin typeface="Arial"/>
-              </a:rPr>
-              <a:t>Confidence gate (“repeat that?”), transcript on both screens, pronunciation lexicon for alerts.</a:t>
+              <a:t>Also handled: </a:t>
+            </a:r>
+            <a:r>
+              <a:rPr sz="1050" b="0">
+                <a:solidFill>
+                  <a:srgbClr val="262626"/>
+                </a:solidFill>
+                <a:latin typeface="Arial"/>
+              </a:rPr>
+              <a:t>Wi-Fi Direct flakiness (hotspot+NSD default, BT RFCOMM backup) · Android bg-audio policy (fg-service built first, compiling) · TTS export scope (4 languages, NVIDIA-Riva recipe, eSpeak-NG meanwhile).</a:t>
             </a:r>
           </a:p>
         </p:txBody>
       </p:sp>
       <p:pic>
         <p:nvPicPr>
-          <p:cNvPr id="17416" name="Picture 17415" descr="feasibility-card.png"/>
+          <p:cNvPr id="17414" name="Picture 17413" descr="feasibility-card.png"/>
           <p:cNvPicPr>
             <a:picLocks noChangeAspect="1"/>
           </p:cNvPicPr>
@@ -9157,8 +8421,8 @@
         </p:blipFill>
         <p:spPr>
           <a:xfrm>
-            <a:off x="8211312" y="914400"/>
-            <a:ext cx="3758184" cy="5385816"/>
+            <a:off x="8092440" y="960120"/>
+            <a:ext cx="3703320" cy="5308092"/>
           </a:xfrm>
           <a:prstGeom prst="rect">
             <a:avLst/>
@@ -9548,14 +8812,221 @@
       </p:pic>
       <p:sp>
         <p:nvSpPr>
-          <p:cNvPr id="17410" name="TextBox 17409"/>
+          <p:cNvPr id="17410" name="Rounded Rectangle 17409"/>
+          <p:cNvSpPr/>
+          <p:nvPr/>
+        </p:nvSpPr>
+        <p:spPr>
+          <a:xfrm>
+            <a:off x="320040" y="1097280"/>
+            <a:ext cx="5623560" cy="2377440"/>
+          </a:xfrm>
+          <a:prstGeom prst="roundRect">
+            <a:avLst/>
+          </a:prstGeom>
+          <a:solidFill>
+            <a:srgbClr val="F5F8FC"/>
+          </a:solidFill>
+          <a:ln w="15875">
+            <a:solidFill>
+              <a:srgbClr val="1F3864"/>
+            </a:solidFill>
+          </a:ln>
+          <a:effectLst/>
+        </p:spPr>
+        <p:style>
+          <a:lnRef idx="1">
+            <a:schemeClr val="accent1"/>
+          </a:lnRef>
+          <a:fillRef idx="3">
+            <a:schemeClr val="accent1"/>
+          </a:fillRef>
+          <a:effectRef idx="2">
+            <a:schemeClr val="accent1"/>
+          </a:effectRef>
+          <a:fontRef idx="minor">
+            <a:schemeClr val="lt1"/>
+          </a:fontRef>
+        </p:style>
+        <p:txBody>
+          <a:bodyPr rtlCol="0" anchor="ctr" wrap="square" bIns="36576"/>
+          <a:lstStyle/>
+          <a:p>
+            <a:pPr algn="ctr">
+              <a:spcAft>
+                <a:spcPts val="400"/>
+              </a:spcAft>
+            </a:pPr>
+            <a:r>
+              <a:rPr sz="1350" b="1">
+                <a:solidFill>
+                  <a:srgbClr val="1F3864"/>
+                </a:solidFill>
+                <a:latin typeface="Arial"/>
+              </a:rPr>
+              <a:t>Potential Impacts</a:t>
+            </a:r>
+          </a:p>
+          <a:p>
+            <a:pPr>
+              <a:lnSpc>
+                <a:spcPct val="103000"/>
+              </a:lnSpc>
+              <a:spcAft>
+                <a:spcPts val="400"/>
+              </a:spcAft>
+            </a:pPr>
+            <a:r>
+              <a:rPr sz="1050" b="0">
+                <a:solidFill>
+                  <a:srgbClr val="262626"/>
+                </a:solidFill>
+                <a:latin typeface="Arial"/>
+              </a:rPr>
+              <a:t>• </a:t>
+            </a:r>
+            <a:r>
+              <a:rPr sz="1050" b="1">
+                <a:solidFill>
+                  <a:srgbClr val="262626"/>
+                </a:solidFill>
+                <a:latin typeface="Arial"/>
+              </a:rPr>
+              <a:t>Last-mile inclusion: </a:t>
+            </a:r>
+            <a:r>
+              <a:rPr sz="1050" b="0">
+                <a:solidFill>
+                  <a:srgbClr val="262626"/>
+                </a:solidFill>
+                <a:latin typeface="Arial"/>
+              </a:rPr>
+              <a:t>voice-native comms for the ~50% of rural women and 1-in-3 rural Indians whom text alerts miss — in their own language.</a:t>
+            </a:r>
+          </a:p>
+          <a:p>
+            <a:pPr>
+              <a:lnSpc>
+                <a:spcPct val="103000"/>
+              </a:lnSpc>
+              <a:spcAft>
+                <a:spcPts val="400"/>
+              </a:spcAft>
+            </a:pPr>
+            <a:r>
+              <a:rPr sz="1050" b="0">
+                <a:solidFill>
+                  <a:srgbClr val="262626"/>
+                </a:solidFill>
+                <a:latin typeface="Arial"/>
+              </a:rPr>
+              <a:t>• </a:t>
+            </a:r>
+            <a:r>
+              <a:rPr sz="1050" b="1">
+                <a:solidFill>
+                  <a:srgbClr val="262626"/>
+                </a:solidFill>
+                <a:latin typeface="Arial"/>
+              </a:rPr>
+              <a:t>Completes ISRO’s disaster stack: </a:t>
+            </a:r>
+            <a:r>
+              <a:rPr sz="1050" b="0">
+                <a:solidFill>
+                  <a:srgbClr val="262626"/>
+                </a:solidFill>
+                <a:latin typeface="Arial"/>
+              </a:rPr>
+              <a:t>the multilingual voice layer for GSAT mobile-radio / VSAT–SDMA low-bitrate links.</a:t>
+            </a:r>
+          </a:p>
+          <a:p>
+            <a:pPr>
+              <a:lnSpc>
+                <a:spcPct val="103000"/>
+              </a:lnSpc>
+              <a:spcAft>
+                <a:spcPts val="400"/>
+              </a:spcAft>
+            </a:pPr>
+            <a:r>
+              <a:rPr sz="1050" b="0">
+                <a:solidFill>
+                  <a:srgbClr val="262626"/>
+                </a:solidFill>
+                <a:latin typeface="Arial"/>
+              </a:rPr>
+              <a:t>• </a:t>
+            </a:r>
+            <a:r>
+              <a:rPr sz="1050" b="1">
+                <a:solidFill>
+                  <a:srgbClr val="262626"/>
+                </a:solidFill>
+                <a:latin typeface="Arial"/>
+              </a:rPr>
+              <a:t>Resilience economics: </a:t>
+            </a:r>
+            <a:r>
+              <a:rPr sz="1050" b="0">
+                <a:solidFill>
+                  <a:srgbClr val="262626"/>
+                </a:solidFill>
+                <a:latin typeface="Arial"/>
+              </a:rPr>
+              <a:t>phones + ₹1,650 LoRa node vs ₹8,000–25,000 hardware walkie-talkie pairs.</a:t>
+            </a:r>
+          </a:p>
+          <a:p>
+            <a:pPr>
+              <a:lnSpc>
+                <a:spcPct val="103000"/>
+              </a:lnSpc>
+              <a:spcAft>
+                <a:spcPts val="400"/>
+              </a:spcAft>
+            </a:pPr>
+            <a:r>
+              <a:rPr sz="1050" b="0">
+                <a:solidFill>
+                  <a:srgbClr val="262626"/>
+                </a:solidFill>
+                <a:latin typeface="Arial"/>
+              </a:rPr>
+              <a:t>• </a:t>
+            </a:r>
+            <a:r>
+              <a:rPr sz="1050" b="1">
+                <a:solidFill>
+                  <a:srgbClr val="262626"/>
+                </a:solidFill>
+                <a:latin typeface="Arial"/>
+              </a:rPr>
+              <a:t>Research → reality: </a:t>
+            </a:r>
+            <a:r>
+              <a:rPr sz="1050" b="0">
+                <a:solidFill>
+                  <a:srgbClr val="262626"/>
+                </a:solidFill>
+                <a:latin typeface="Arial"/>
+              </a:rPr>
+              <a:t>a deployable Indian instance of 6G semantic communication.</a:t>
+            </a:r>
+          </a:p>
+        </p:txBody>
+      </p:sp>
+      <p:sp>
+        <p:nvSpPr>
+          <p:cNvPr id="17411" name="TextBox 17410"/>
           <p:cNvSpPr txBox="1"/>
           <p:nvPr/>
         </p:nvSpPr>
         <p:spPr>
           <a:xfrm>
-            <a:off x="393192" y="941832"/>
-            <a:ext cx="6766560" cy="2468880"/>
+            <a:off x="6172200" y="932688"/>
+            <a:ext cx="5715000" cy="914400"/>
           </a:xfrm>
           <a:prstGeom prst="rect">
             <a:avLst/>
@@ -9568,174 +9039,51 @@
           </a:bodyPr>
           <a:lstStyle/>
           <a:p>
-            <a:pPr>
+            <a:pPr algn="ctr">
               <a:spcAft>
-                <a:spcPts val="400"/>
+                <a:spcPts val="100"/>
               </a:spcAft>
             </a:pPr>
             <a:r>
-              <a:rPr sz="1400" b="1">
-                <a:solidFill>
-                  <a:srgbClr val="1F3864"/>
-                </a:solidFill>
-                <a:latin typeface="Arial"/>
-              </a:rPr>
-              <a:t>Potential Impacts</a:t>
-            </a:r>
-          </a:p>
-          <a:p>
-            <a:pPr>
-              <a:lnSpc>
-                <a:spcPct val="100000"/>
-              </a:lnSpc>
+              <a:rPr sz="4000" b="1">
+                <a:solidFill>
+                  <a:srgbClr val="C55A11"/>
+                </a:solidFill>
+                <a:latin typeface="Arial"/>
+              </a:rPr>
+              <a:t>45 bytes</a:t>
+            </a:r>
+            <a:r>
+              <a:rPr sz="1600" b="1">
+                <a:solidFill>
+                  <a:srgbClr val="262626"/>
+                </a:solidFill>
+                <a:latin typeface="Arial"/>
+              </a:rPr>
+              <a:t>  = one spoken sentence</a:t>
+            </a:r>
+          </a:p>
+          <a:p>
+            <a:pPr algn="ctr">
               <a:spcAft>
-                <a:spcPts val="400"/>
+                <a:spcPts val="0"/>
               </a:spcAft>
             </a:pPr>
             <a:r>
-              <a:rPr sz="1150" b="0">
-                <a:solidFill>
-                  <a:srgbClr val="262626"/>
-                </a:solidFill>
-                <a:latin typeface="Arial"/>
-              </a:rPr>
-              <a:t>• </a:t>
-            </a:r>
-            <a:r>
-              <a:rPr sz="1150" b="1">
-                <a:solidFill>
-                  <a:srgbClr val="262626"/>
-                </a:solidFill>
-                <a:latin typeface="Arial"/>
-              </a:rPr>
-              <a:t>Last-mile inclusion: </a:t>
-            </a:r>
-            <a:r>
-              <a:rPr sz="1150" b="0">
-                <a:solidFill>
-                  <a:srgbClr val="262626"/>
-                </a:solidFill>
-                <a:latin typeface="Arial"/>
-              </a:rPr>
-              <a:t>voice-native two-way comms reach the ~50% of rural women and 1-in-3 rural Indians whom text alerts miss — in their own language.</a:t>
-            </a:r>
-          </a:p>
-          <a:p>
-            <a:pPr>
-              <a:lnSpc>
-                <a:spcPct val="100000"/>
-              </a:lnSpc>
-              <a:spcAft>
-                <a:spcPts val="400"/>
-              </a:spcAft>
-            </a:pPr>
-            <a:r>
-              <a:rPr sz="1150" b="0">
-                <a:solidFill>
-                  <a:srgbClr val="262626"/>
-                </a:solidFill>
-                <a:latin typeface="Arial"/>
-              </a:rPr>
-              <a:t>• </a:t>
-            </a:r>
-            <a:r>
-              <a:rPr sz="1150" b="1">
-                <a:solidFill>
-                  <a:srgbClr val="262626"/>
-                </a:solidFill>
-                <a:latin typeface="Arial"/>
-              </a:rPr>
-              <a:t>Completes ISRO’s disaster stack: </a:t>
-            </a:r>
-            <a:r>
-              <a:rPr sz="1150" b="0">
-                <a:solidFill>
-                  <a:srgbClr val="262626"/>
-                </a:solidFill>
-                <a:latin typeface="Arial"/>
-              </a:rPr>
-              <a:t>the multilingual voice layer for GSAT mobile-radio / VSAT–SDMA low-bitrate links (DMS programme).</a:t>
-            </a:r>
-          </a:p>
-          <a:p>
-            <a:pPr>
-              <a:lnSpc>
-                <a:spcPct val="100000"/>
-              </a:lnSpc>
-              <a:spcAft>
-                <a:spcPts val="400"/>
-              </a:spcAft>
-            </a:pPr>
-            <a:r>
-              <a:rPr sz="1150" b="0">
-                <a:solidFill>
-                  <a:srgbClr val="262626"/>
-                </a:solidFill>
-                <a:latin typeface="Arial"/>
-              </a:rPr>
-              <a:t>• </a:t>
-            </a:r>
-            <a:r>
-              <a:rPr sz="1150" b="1">
-                <a:solidFill>
-                  <a:srgbClr val="262626"/>
-                </a:solidFill>
-                <a:latin typeface="Arial"/>
-              </a:rPr>
-              <a:t>Resilience economics: </a:t>
-            </a:r>
-            <a:r>
-              <a:rPr sz="1150" b="0">
-                <a:solidFill>
-                  <a:srgbClr val="262626"/>
-                </a:solidFill>
-                <a:latin typeface="Arial"/>
-              </a:rPr>
-              <a:t>existing phones + ₹1,650 LoRa node vs ₹8,000–25,000 hardware walkie-talkie pairs.</a:t>
-            </a:r>
-          </a:p>
-          <a:p>
-            <a:pPr>
-              <a:lnSpc>
-                <a:spcPct val="100000"/>
-              </a:lnSpc>
-              <a:spcAft>
-                <a:spcPts val="400"/>
-              </a:spcAft>
-            </a:pPr>
-            <a:r>
-              <a:rPr sz="1150" b="0">
-                <a:solidFill>
-                  <a:srgbClr val="262626"/>
-                </a:solidFill>
-                <a:latin typeface="Arial"/>
-              </a:rPr>
-              <a:t>• </a:t>
-            </a:r>
-            <a:r>
-              <a:rPr sz="1150" b="1">
-                <a:solidFill>
-                  <a:srgbClr val="262626"/>
-                </a:solidFill>
-                <a:latin typeface="Arial"/>
-              </a:rPr>
-              <a:t>Research → reality: </a:t>
-            </a:r>
-            <a:r>
-              <a:rPr sz="1150" b="0">
-                <a:solidFill>
-                  <a:srgbClr val="262626"/>
-                </a:solidFill>
-                <a:latin typeface="Arial"/>
-              </a:rPr>
-              <a:t>a deployable Indian instance of 6G semantic communication.</a:t>
+              <a:rPr sz="1250" b="0">
+                <a:solidFill>
+                  <a:srgbClr val="262626"/>
+                </a:solidFill>
+                <a:latin typeface="Arial"/>
+              </a:rPr>
+              <a:t>vs 7,625 B cellular (AMR-NB) · 40,000 B raw voice (G.711)</a:t>
             </a:r>
           </a:p>
         </p:txBody>
       </p:sp>
       <p:pic>
         <p:nvPicPr>
-          <p:cNvPr id="17411" name="Picture 17410" descr="chart-bytes.png"/>
+          <p:cNvPr id="17412" name="Picture 17411" descr="chart-bytes.png"/>
           <p:cNvPicPr>
             <a:picLocks noChangeAspect="1"/>
           </p:cNvPicPr>
@@ -9749,17 +9097,187 @@
         </p:blipFill>
         <p:spPr>
           <a:xfrm>
-            <a:off x="7388352" y="941832"/>
-            <a:ext cx="4572000" cy="2395728"/>
+            <a:off x="6355080" y="1938528"/>
+            <a:ext cx="5212080" cy="2842953"/>
           </a:xfrm>
           <a:prstGeom prst="rect">
             <a:avLst/>
           </a:prstGeom>
         </p:spPr>
       </p:pic>
+      <p:sp>
+        <p:nvSpPr>
+          <p:cNvPr id="17413" name="Rounded Rectangle 17412"/>
+          <p:cNvSpPr/>
+          <p:nvPr/>
+        </p:nvSpPr>
+        <p:spPr>
+          <a:xfrm>
+            <a:off x="6172200" y="4873752"/>
+            <a:ext cx="5715000" cy="1389888"/>
+          </a:xfrm>
+          <a:prstGeom prst="roundRect">
+            <a:avLst/>
+          </a:prstGeom>
+          <a:solidFill>
+            <a:srgbClr val="F5F8FC"/>
+          </a:solidFill>
+          <a:ln w="15875">
+            <a:solidFill>
+              <a:srgbClr val="1F3864"/>
+            </a:solidFill>
+          </a:ln>
+          <a:effectLst/>
+        </p:spPr>
+        <p:style>
+          <a:lnRef idx="1">
+            <a:schemeClr val="accent1"/>
+          </a:lnRef>
+          <a:fillRef idx="3">
+            <a:schemeClr val="accent1"/>
+          </a:fillRef>
+          <a:effectRef idx="2">
+            <a:schemeClr val="accent1"/>
+          </a:effectRef>
+          <a:fontRef idx="minor">
+            <a:schemeClr val="lt1"/>
+          </a:fontRef>
+        </p:style>
+        <p:txBody>
+          <a:bodyPr rtlCol="0" anchor="ctr" wrap="square" bIns="36576"/>
+          <a:lstStyle/>
+          <a:p>
+            <a:pPr algn="ctr">
+              <a:spcAft>
+                <a:spcPts val="300"/>
+              </a:spcAft>
+            </a:pPr>
+            <a:r>
+              <a:rPr sz="1250" b="1">
+                <a:solidFill>
+                  <a:srgbClr val="1F3864"/>
+                </a:solidFill>
+                <a:latin typeface="Arial"/>
+              </a:rPr>
+              <a:t>Benefits</a:t>
+            </a:r>
+          </a:p>
+          <a:p>
+            <a:pPr>
+              <a:lnSpc>
+                <a:spcPct val="100000"/>
+              </a:lnSpc>
+              <a:spcAft>
+                <a:spcPts val="250"/>
+              </a:spcAft>
+            </a:pPr>
+            <a:r>
+              <a:rPr sz="1000" b="0">
+                <a:solidFill>
+                  <a:srgbClr val="262626"/>
+                </a:solidFill>
+                <a:latin typeface="Arial"/>
+              </a:rPr>
+              <a:t>• </a:t>
+            </a:r>
+            <a:r>
+              <a:rPr sz="1000" b="1">
+                <a:solidFill>
+                  <a:srgbClr val="262626"/>
+                </a:solidFill>
+                <a:latin typeface="Arial"/>
+              </a:rPr>
+              <a:t>Social: </a:t>
+            </a:r>
+            <a:r>
+              <a:rPr sz="1000" b="0">
+                <a:solidFill>
+                  <a:srgbClr val="262626"/>
+                </a:solidFill>
+                <a:latin typeface="Arial"/>
+              </a:rPr>
+              <a:t>literacy-independent · 10 languages ≈ 85%+ of India · voice + transcript serve both impairments.</a:t>
+            </a:r>
+          </a:p>
+          <a:p>
+            <a:pPr>
+              <a:lnSpc>
+                <a:spcPct val="100000"/>
+              </a:lnSpc>
+              <a:spcAft>
+                <a:spcPts val="250"/>
+              </a:spcAft>
+            </a:pPr>
+            <a:r>
+              <a:rPr sz="1000" b="0">
+                <a:solidFill>
+                  <a:srgbClr val="262626"/>
+                </a:solidFill>
+                <a:latin typeface="Arial"/>
+              </a:rPr>
+              <a:t>• </a:t>
+            </a:r>
+            <a:r>
+              <a:rPr sz="1000" b="1">
+                <a:solidFill>
+                  <a:srgbClr val="262626"/>
+                </a:solidFill>
+                <a:latin typeface="Arial"/>
+              </a:rPr>
+              <a:t>Economic &amp; strategic: </a:t>
+            </a:r>
+            <a:r>
+              <a:rPr sz="1000" b="0">
+                <a:solidFill>
+                  <a:srgbClr val="262626"/>
+                </a:solidFill>
+                <a:latin typeface="Arial"/>
+              </a:rPr>
+              <a:t>zero recurring cost (no SIM/server) · sovereign stack: Indian models, IN865 band, no foreign cloud.</a:t>
+            </a:r>
+          </a:p>
+          <a:p>
+            <a:pPr>
+              <a:lnSpc>
+                <a:spcPct val="100000"/>
+              </a:lnSpc>
+              <a:spcAft>
+                <a:spcPts val="250"/>
+              </a:spcAft>
+            </a:pPr>
+            <a:r>
+              <a:rPr sz="1000" b="0">
+                <a:solidFill>
+                  <a:srgbClr val="262626"/>
+                </a:solidFill>
+                <a:latin typeface="Arial"/>
+              </a:rPr>
+              <a:t>• </a:t>
+            </a:r>
+            <a:r>
+              <a:rPr sz="1000" b="1">
+                <a:solidFill>
+                  <a:srgbClr val="262626"/>
+                </a:solidFill>
+                <a:latin typeface="Arial"/>
+              </a:rPr>
+              <a:t>Operational: </a:t>
+            </a:r>
+            <a:r>
+              <a:rPr sz="1000" b="0">
+                <a:solidFill>
+                  <a:srgbClr val="262626"/>
+                </a:solidFill>
+                <a:latin typeface="Arial"/>
+              </a:rPr>
+              <a:t>int8-efficient; LoRa nodes run days on a power bank — solar-deployable in a blackout.</a:t>
+            </a:r>
+          </a:p>
+        </p:txBody>
+      </p:sp>
       <p:pic>
         <p:nvPicPr>
-          <p:cNvPr id="17412" name="Picture 17411" descr="chart-bitschar.png"/>
+          <p:cNvPr id="17414" name="Picture 17413" descr="chart-bitschar.png"/>
           <p:cNvPicPr>
             <a:picLocks noChangeAspect="1"/>
           </p:cNvPicPr>
@@ -9773,201 +9291,14 @@
         </p:blipFill>
         <p:spPr>
           <a:xfrm>
-            <a:off x="484632" y="3611880"/>
-            <a:ext cx="4480560" cy="2395728"/>
+            <a:off x="502920" y="3584448"/>
+            <a:ext cx="5074920" cy="2768138"/>
           </a:xfrm>
           <a:prstGeom prst="rect">
             <a:avLst/>
           </a:prstGeom>
         </p:spPr>
       </p:pic>
-      <p:sp>
-        <p:nvSpPr>
-          <p:cNvPr id="17413" name="TextBox 17412"/>
-          <p:cNvSpPr txBox="1"/>
-          <p:nvPr/>
-        </p:nvSpPr>
-        <p:spPr>
-          <a:xfrm>
-            <a:off x="5321808" y="3611880"/>
-            <a:ext cx="6492240" cy="2560320"/>
-          </a:xfrm>
-          <a:prstGeom prst="rect">
-            <a:avLst/>
-          </a:prstGeom>
-          <a:noFill/>
-        </p:spPr>
-        <p:txBody>
-          <a:bodyPr wrap="square">
-            <a:spAutoFit/>
-          </a:bodyPr>
-          <a:lstStyle/>
-          <a:p>
-            <a:pPr>
-              <a:spcAft>
-                <a:spcPts val="400"/>
-              </a:spcAft>
-            </a:pPr>
-            <a:r>
-              <a:rPr sz="1400" b="1">
-                <a:solidFill>
-                  <a:srgbClr val="C55A11"/>
-                </a:solidFill>
-                <a:latin typeface="Arial"/>
-              </a:rPr>
-              <a:t>Benefits</a:t>
-            </a:r>
-          </a:p>
-          <a:p>
-            <a:pPr>
-              <a:lnSpc>
-                <a:spcPct val="100000"/>
-              </a:lnSpc>
-              <a:spcAft>
-                <a:spcPts val="400"/>
-              </a:spcAft>
-            </a:pPr>
-            <a:r>
-              <a:rPr sz="1150" b="0">
-                <a:solidFill>
-                  <a:srgbClr val="262626"/>
-                </a:solidFill>
-                <a:latin typeface="Arial"/>
-              </a:rPr>
-              <a:t>• </a:t>
-            </a:r>
-            <a:r>
-              <a:rPr sz="1150" b="1">
-                <a:solidFill>
-                  <a:srgbClr val="262626"/>
-                </a:solidFill>
-                <a:latin typeface="Arial"/>
-              </a:rPr>
-              <a:t>Social: </a:t>
-            </a:r>
-            <a:r>
-              <a:rPr sz="1150" b="0">
-                <a:solidFill>
-                  <a:srgbClr val="262626"/>
-                </a:solidFill>
-                <a:latin typeface="Arial"/>
-              </a:rPr>
-              <a:t>literacy-independent; 10 languages ≈ 85%+ of India; voice serves visually-impaired, transcript serves hearing-impaired.</a:t>
-            </a:r>
-          </a:p>
-          <a:p>
-            <a:pPr>
-              <a:lnSpc>
-                <a:spcPct val="100000"/>
-              </a:lnSpc>
-              <a:spcAft>
-                <a:spcPts val="400"/>
-              </a:spcAft>
-            </a:pPr>
-            <a:r>
-              <a:rPr sz="1150" b="0">
-                <a:solidFill>
-                  <a:srgbClr val="262626"/>
-                </a:solidFill>
-                <a:latin typeface="Arial"/>
-              </a:rPr>
-              <a:t>• </a:t>
-            </a:r>
-            <a:r>
-              <a:rPr sz="1150" b="1">
-                <a:solidFill>
-                  <a:srgbClr val="262626"/>
-                </a:solidFill>
-                <a:latin typeface="Arial"/>
-              </a:rPr>
-              <a:t>Economic: </a:t>
-            </a:r>
-            <a:r>
-              <a:rPr sz="1150" b="0">
-                <a:solidFill>
-                  <a:srgbClr val="262626"/>
-                </a:solidFill>
-                <a:latin typeface="Arial"/>
-              </a:rPr>
-              <a:t>zero recurring cost — no SIM, no data plan, no server; open-source, procurement-friendly.</a:t>
-            </a:r>
-          </a:p>
-          <a:p>
-            <a:pPr>
-              <a:lnSpc>
-                <a:spcPct val="100000"/>
-              </a:lnSpc>
-              <a:spcAft>
-                <a:spcPts val="400"/>
-              </a:spcAft>
-            </a:pPr>
-            <a:r>
-              <a:rPr sz="1150" b="0">
-                <a:solidFill>
-                  <a:srgbClr val="262626"/>
-                </a:solidFill>
-                <a:latin typeface="Arial"/>
-              </a:rPr>
-              <a:t>• </a:t>
-            </a:r>
-            <a:r>
-              <a:rPr sz="1150" b="1">
-                <a:solidFill>
-                  <a:srgbClr val="262626"/>
-                </a:solidFill>
-                <a:latin typeface="Arial"/>
-              </a:rPr>
-              <a:t>Strategic: </a:t>
-            </a:r>
-            <a:r>
-              <a:rPr sz="1150" b="0">
-                <a:solidFill>
-                  <a:srgbClr val="262626"/>
-                </a:solidFill>
-                <a:latin typeface="Arial"/>
-              </a:rPr>
-              <a:t>sovereign stack — Indian models (Bhashini/AI4Bharat), Indian band plan (IN865), no foreign cloud.</a:t>
-            </a:r>
-          </a:p>
-          <a:p>
-            <a:pPr>
-              <a:lnSpc>
-                <a:spcPct val="100000"/>
-              </a:lnSpc>
-              <a:spcAft>
-                <a:spcPts val="400"/>
-              </a:spcAft>
-            </a:pPr>
-            <a:r>
-              <a:rPr sz="1150" b="0">
-                <a:solidFill>
-                  <a:srgbClr val="262626"/>
-                </a:solidFill>
-                <a:latin typeface="Arial"/>
-              </a:rPr>
-              <a:t>• </a:t>
-            </a:r>
-            <a:r>
-              <a:rPr sz="1150" b="1">
-                <a:solidFill>
-                  <a:srgbClr val="262626"/>
-                </a:solidFill>
-                <a:latin typeface="Arial"/>
-              </a:rPr>
-              <a:t>Environmental / operational: </a:t>
-            </a:r>
-            <a:r>
-              <a:rPr sz="1150" b="0">
-                <a:solidFill>
-                  <a:srgbClr val="262626"/>
-                </a:solidFill>
-                <a:latin typeface="Arial"/>
-              </a:rPr>
-              <a:t>int8-efficient; LoRa nodes run days on a power bank — works on solar in a blackout.</a:t>
-            </a:r>
-          </a:p>
-        </p:txBody>
-      </p:sp>
     </p:spTree>
     <p:extLst>
       <p:ext uri="{BB962C8B-B14F-4D97-AF65-F5344CB8AC3E}">
@@ -10358,7 +9689,7 @@
         <p:spPr>
           <a:xfrm>
             <a:off x="365760" y="1005840"/>
-            <a:ext cx="11475720" cy="4343400"/>
+            <a:ext cx="11475720" cy="4480560"/>
           </a:xfrm>
           <a:prstGeom prst="rect">
             <a:avLst/>
@@ -10373,14 +9704,14 @@
           <a:p>
             <a:pPr>
               <a:lnSpc>
-                <a:spcPct val="102000"/>
+                <a:spcPct val="105000"/>
               </a:lnSpc>
               <a:spcAft>
-                <a:spcPts val="1200"/>
+                <a:spcPts val="1100"/>
               </a:spcAft>
             </a:pPr>
             <a:r>
-              <a:rPr sz="1200" b="1">
+              <a:rPr sz="1150" b="1">
                 <a:solidFill>
                   <a:srgbClr val="262626"/>
                 </a:solidFill>
@@ -10389,45 +9720,45 @@
               <a:t>1. </a:t>
             </a:r>
             <a:r>
-              <a:rPr sz="1200" b="1">
-                <a:solidFill>
-                  <a:srgbClr val="262626"/>
-                </a:solidFill>
-                <a:latin typeface="Arial"/>
-              </a:rPr>
-              <a:t>Cyclone Amphan outage: </a:t>
-            </a:r>
-            <a:r>
-              <a:rPr sz="1200" b="0">
-                <a:solidFill>
-                  <a:srgbClr val="262626"/>
-                </a:solidFill>
-                <a:latin typeface="Arial"/>
-              </a:rPr>
-              <a:t>~7,000/14,167 WB towers down; 65–70% capacity for days (COAI). </a:t>
-            </a:r>
-            <a:r>
-              <a:rPr sz="1200" b="0">
+              <a:rPr sz="1150" b="1">
+                <a:solidFill>
+                  <a:srgbClr val="C55A11"/>
+                </a:solidFill>
+                <a:latin typeface="Arial"/>
+              </a:rPr>
+              <a:t>Project repository: </a:t>
+            </a:r>
+            <a:r>
+              <a:rPr sz="1150" b="0">
+                <a:solidFill>
+                  <a:srgbClr val="262626"/>
+                </a:solidFill>
+                <a:latin typeface="Arial"/>
+              </a:rPr>
+              <a:t>Kotlin app + evaluation harness + firmware — private; jury access on submission. </a:t>
+            </a:r>
+            <a:r>
+              <a:rPr sz="1150" b="0">
                 <a:solidFill>
                   <a:srgbClr val="0563C1"/>
                 </a:solidFill>
                 <a:latin typeface="Arial"/>
                 <a:hlinkClick r:id="rId4"/>
               </a:rPr>
-              <a:t>deccanherald.com</a:t>
+              <a:t>github.com/satyam-mishra-dev/itantra</a:t>
             </a:r>
           </a:p>
           <a:p>
             <a:pPr>
               <a:lnSpc>
-                <a:spcPct val="102000"/>
+                <a:spcPct val="105000"/>
               </a:lnSpc>
               <a:spcAft>
-                <a:spcPts val="1200"/>
+                <a:spcPts val="1100"/>
               </a:spcAft>
             </a:pPr>
             <a:r>
-              <a:rPr sz="1200" b="1">
+              <a:rPr sz="1150" b="1">
                 <a:solidFill>
                   <a:srgbClr val="262626"/>
                 </a:solidFill>
@@ -10436,45 +9767,35 @@
               <a:t>2. </a:t>
             </a:r>
             <a:r>
-              <a:rPr sz="1200" b="1">
-                <a:solidFill>
-                  <a:srgbClr val="262626"/>
-                </a:solidFill>
-                <a:latin typeface="Arial"/>
-              </a:rPr>
-              <a:t>The bitrate math: </a:t>
-            </a:r>
-            <a:r>
-              <a:rPr sz="1200" b="0">
-                <a:solidFill>
-                  <a:srgbClr val="262626"/>
-                </a:solidFill>
-                <a:latin typeface="Arial"/>
-              </a:rPr>
-              <a:t>MELPe 600 bps (STANAG 4591) &amp; Codec2 450 bps vs speech-as-text ≈107 bps. </a:t>
-            </a:r>
-            <a:r>
-              <a:rPr sz="1200" b="0">
-                <a:solidFill>
-                  <a:srgbClr val="0563C1"/>
-                </a:solidFill>
-                <a:latin typeface="Arial"/>
-                <a:hlinkClick r:id="rId5"/>
-              </a:rPr>
-              <a:t>melp.org · github.com/drowe67/codec2</a:t>
+              <a:rPr sz="1150" b="1">
+                <a:solidFill>
+                  <a:srgbClr val="C55A11"/>
+                </a:solidFill>
+                <a:latin typeface="Arial"/>
+              </a:rPr>
+              <a:t>Working demo: </a:t>
+            </a:r>
+            <a:r>
+              <a:rPr sz="1150" b="0">
+                <a:solidFill>
+                  <a:srgbClr val="262626"/>
+                </a:solidFill>
+                <a:latin typeface="Arial"/>
+              </a:rPr>
+              <a:t>compiling APK + measured benchmark CSVs live in the repo; demo video added on submission. </a:t>
             </a:r>
           </a:p>
           <a:p>
             <a:pPr>
               <a:lnSpc>
-                <a:spcPct val="102000"/>
+                <a:spcPct val="105000"/>
               </a:lnSpc>
               <a:spcAft>
-                <a:spcPts val="1200"/>
+                <a:spcPts val="1100"/>
               </a:spcAft>
             </a:pPr>
             <a:r>
-              <a:rPr sz="1200" b="1">
+              <a:rPr sz="1150" b="1">
                 <a:solidFill>
                   <a:srgbClr val="262626"/>
                 </a:solidFill>
@@ -10483,45 +9804,45 @@
               <a:t>3. </a:t>
             </a:r>
             <a:r>
-              <a:rPr sz="1200" b="1">
-                <a:solidFill>
-                  <a:srgbClr val="262626"/>
-                </a:solidFill>
-                <a:latin typeface="Arial"/>
-              </a:rPr>
-              <a:t>Semantic communications survey: </a:t>
-            </a:r>
-            <a:r>
-              <a:rPr sz="1200" b="0">
-                <a:solidFill>
-                  <a:srgbClr val="262626"/>
-                </a:solidFill>
-                <a:latin typeface="Arial"/>
-              </a:rPr>
-              <a:t>Qin, Tao, Lu, Tong &amp; Li, 2021. </a:t>
-            </a:r>
-            <a:r>
-              <a:rPr sz="1200" b="0">
+              <a:rPr sz="1150" b="1">
+                <a:solidFill>
+                  <a:srgbClr val="1F3864"/>
+                </a:solidFill>
+                <a:latin typeface="Arial"/>
+              </a:rPr>
+              <a:t>Cyclone Amphan outage: </a:t>
+            </a:r>
+            <a:r>
+              <a:rPr sz="1150" b="0">
+                <a:solidFill>
+                  <a:srgbClr val="262626"/>
+                </a:solidFill>
+                <a:latin typeface="Arial"/>
+              </a:rPr>
+              <a:t>~7,000 of 14,167 WB towers down; networks at 65–70% capacity for days (COAI). </a:t>
+            </a:r>
+            <a:r>
+              <a:rPr sz="1150" b="0">
                 <a:solidFill>
                   <a:srgbClr val="0563C1"/>
                 </a:solidFill>
                 <a:latin typeface="Arial"/>
-                <a:hlinkClick r:id="rId6"/>
-              </a:rPr>
-              <a:t>arxiv.org/abs/2201.01389</a:t>
+                <a:hlinkClick r:id="rId5"/>
+              </a:rPr>
+              <a:t>deccanherald.com</a:t>
             </a:r>
           </a:p>
           <a:p>
             <a:pPr>
               <a:lnSpc>
-                <a:spcPct val="102000"/>
+                <a:spcPct val="105000"/>
               </a:lnSpc>
               <a:spcAft>
-                <a:spcPts val="1200"/>
+                <a:spcPts val="1100"/>
               </a:spcAft>
             </a:pPr>
             <a:r>
-              <a:rPr sz="1200" b="1">
+              <a:rPr sz="1150" b="1">
                 <a:solidFill>
                   <a:srgbClr val="262626"/>
                 </a:solidFill>
@@ -10530,45 +9851,45 @@
               <a:t>4. </a:t>
             </a:r>
             <a:r>
-              <a:rPr sz="1200" b="1">
-                <a:solidFill>
-                  <a:srgbClr val="262626"/>
-                </a:solidFill>
-                <a:latin typeface="Arial"/>
-              </a:rPr>
-              <a:t>DeepSC-ST: </a:t>
-            </a:r>
-            <a:r>
-              <a:rPr sz="1200" b="0">
-                <a:solidFill>
-                  <a:srgbClr val="262626"/>
-                </a:solidFill>
-                <a:latin typeface="Arial"/>
-              </a:rPr>
-              <a:t>recognition-domain speech transceiver, IEEE Trans. Wireless Comm. 2023. </a:t>
-            </a:r>
-            <a:r>
-              <a:rPr sz="1200" b="0">
+              <a:rPr sz="1150" b="1">
+                <a:solidFill>
+                  <a:srgbClr val="1F3864"/>
+                </a:solidFill>
+                <a:latin typeface="Arial"/>
+              </a:rPr>
+              <a:t>The bitrate math: </a:t>
+            </a:r>
+            <a:r>
+              <a:rPr sz="1150" b="0">
+                <a:solidFill>
+                  <a:srgbClr val="262626"/>
+                </a:solidFill>
+                <a:latin typeface="Arial"/>
+              </a:rPr>
+              <a:t>MELPe 600 bps (NATO STANAG 4591) and Codec2 450 bps vs speech-as-text ≈ 107 bps. </a:t>
+            </a:r>
+            <a:r>
+              <a:rPr sz="1150" b="0">
                 <a:solidFill>
                   <a:srgbClr val="0563C1"/>
                 </a:solidFill>
                 <a:latin typeface="Arial"/>
-                <a:hlinkClick r:id="rId7"/>
-              </a:rPr>
-              <a:t>doi.org/10.1109/TWC.2023.3240969</a:t>
+                <a:hlinkClick r:id="rId6"/>
+              </a:rPr>
+              <a:t>melp.org · github.com/drowe67/codec2</a:t>
             </a:r>
           </a:p>
           <a:p>
             <a:pPr>
               <a:lnSpc>
-                <a:spcPct val="102000"/>
+                <a:spcPct val="105000"/>
               </a:lnSpc>
               <a:spcAft>
-                <a:spcPts val="1200"/>
+                <a:spcPts val="1100"/>
               </a:spcAft>
             </a:pPr>
             <a:r>
-              <a:rPr sz="1200" b="1">
+              <a:rPr sz="1150" b="1">
                 <a:solidFill>
                   <a:srgbClr val="262626"/>
                 </a:solidFill>
@@ -10577,45 +9898,45 @@
               <a:t>5. </a:t>
             </a:r>
             <a:r>
-              <a:rPr sz="1200" b="1">
-                <a:solidFill>
-                  <a:srgbClr val="262626"/>
-                </a:solidFill>
-                <a:latin typeface="Arial"/>
-              </a:rPr>
-              <a:t>STT over low-rate links: </a:t>
-            </a:r>
-            <a:r>
-              <a:rPr sz="1200" b="0">
-                <a:solidFill>
-                  <a:srgbClr val="262626"/>
-                </a:solidFill>
-                <a:latin typeface="Arial"/>
-              </a:rPr>
-              <a:t>up to 94% latency reduction vs compressed audio (2025). </a:t>
-            </a:r>
-            <a:r>
-              <a:rPr sz="1200" b="0">
+              <a:rPr sz="1150" b="1">
+                <a:solidFill>
+                  <a:srgbClr val="1F3864"/>
+                </a:solidFill>
+                <a:latin typeface="Arial"/>
+              </a:rPr>
+              <a:t>Semantic communications (foundational survey): </a:t>
+            </a:r>
+            <a:r>
+              <a:rPr sz="1150" b="0">
+                <a:solidFill>
+                  <a:srgbClr val="262626"/>
+                </a:solidFill>
+                <a:latin typeface="Arial"/>
+              </a:rPr>
+              <a:t>Qin, Tao, Lu, Tong &amp; Li, 2021. </a:t>
+            </a:r>
+            <a:r>
+              <a:rPr sz="1150" b="0">
                 <a:solidFill>
                   <a:srgbClr val="0563C1"/>
                 </a:solidFill>
                 <a:latin typeface="Arial"/>
-                <a:hlinkClick r:id="rId8"/>
-              </a:rPr>
-              <a:t>researchgate.net/394380603</a:t>
+                <a:hlinkClick r:id="rId7"/>
+              </a:rPr>
+              <a:t>arxiv.org/abs/2201.01389</a:t>
             </a:r>
           </a:p>
           <a:p>
             <a:pPr>
               <a:lnSpc>
-                <a:spcPct val="102000"/>
+                <a:spcPct val="105000"/>
               </a:lnSpc>
               <a:spcAft>
-                <a:spcPts val="1200"/>
+                <a:spcPts val="1100"/>
               </a:spcAft>
             </a:pPr>
             <a:r>
-              <a:rPr sz="1200" b="1">
+              <a:rPr sz="1150" b="1">
                 <a:solidFill>
                   <a:srgbClr val="262626"/>
                 </a:solidFill>
@@ -10624,45 +9945,45 @@
               <a:t>6. </a:t>
             </a:r>
             <a:r>
-              <a:rPr sz="1200" b="1">
-                <a:solidFill>
-                  <a:srgbClr val="262626"/>
-                </a:solidFill>
-                <a:latin typeface="Arial"/>
-              </a:rPr>
-              <a:t>IndicConformer (AI4Bharat): </a:t>
-            </a:r>
-            <a:r>
-              <a:rPr sz="1200" b="0">
-                <a:solidFill>
-                  <a:srgbClr val="262626"/>
-                </a:solidFill>
-                <a:latin typeface="Arial"/>
-              </a:rPr>
-              <a:t>MIT, 22 languages, official int8 ONNX; Hindi WER 13.2 (Vaani). </a:t>
-            </a:r>
-            <a:r>
-              <a:rPr sz="1200" b="0">
+              <a:rPr sz="1150" b="1">
+                <a:solidFill>
+                  <a:srgbClr val="1F3864"/>
+                </a:solidFill>
+                <a:latin typeface="Arial"/>
+              </a:rPr>
+              <a:t>DeepSC-ST: </a:t>
+            </a:r>
+            <a:r>
+              <a:rPr sz="1150" b="0">
+                <a:solidFill>
+                  <a:srgbClr val="262626"/>
+                </a:solidFill>
+                <a:latin typeface="Arial"/>
+              </a:rPr>
+              <a:t>speech transceiver transmitting recognition-domain features, IEEE Trans. Wireless Comm. 2023. </a:t>
+            </a:r>
+            <a:r>
+              <a:rPr sz="1150" b="0">
                 <a:solidFill>
                   <a:srgbClr val="0563C1"/>
                 </a:solidFill>
                 <a:latin typeface="Arial"/>
-                <a:hlinkClick r:id="rId9"/>
-              </a:rPr>
-              <a:t>huggingface.co/ai4bharat</a:t>
+                <a:hlinkClick r:id="rId8"/>
+              </a:rPr>
+              <a:t>doi.org/10.1109/TWC.2023.3240969</a:t>
             </a:r>
           </a:p>
           <a:p>
             <a:pPr>
               <a:lnSpc>
-                <a:spcPct val="102000"/>
+                <a:spcPct val="105000"/>
               </a:lnSpc>
               <a:spcAft>
-                <a:spcPts val="1200"/>
+                <a:spcPts val="1100"/>
               </a:spcAft>
             </a:pPr>
             <a:r>
-              <a:rPr sz="1200" b="1">
+              <a:rPr sz="1150" b="1">
                 <a:solidFill>
                   <a:srgbClr val="262626"/>
                 </a:solidFill>
@@ -10671,45 +9992,45 @@
               <a:t>7. </a:t>
             </a:r>
             <a:r>
-              <a:rPr sz="1200" b="1">
-                <a:solidFill>
-                  <a:srgbClr val="262626"/>
-                </a:solidFill>
-                <a:latin typeface="Arial"/>
-              </a:rPr>
-              <a:t>AI4Bharat Indic-TTS: </a:t>
-            </a:r>
-            <a:r>
-              <a:rPr sz="1200" b="0">
-                <a:solidFill>
-                  <a:srgbClr val="262626"/>
-                </a:solidFill>
-                <a:latin typeface="Arial"/>
-              </a:rPr>
-              <a:t>FastPitch + HiFi-GAN, MIT, 13 Indic languages. </a:t>
-            </a:r>
-            <a:r>
-              <a:rPr sz="1200" b="0">
+              <a:rPr sz="1150" b="1">
+                <a:solidFill>
+                  <a:srgbClr val="1F3864"/>
+                </a:solidFill>
+                <a:latin typeface="Arial"/>
+              </a:rPr>
+              <a:t>STT over low-data-rate networks: </a:t>
+            </a:r>
+            <a:r>
+              <a:rPr sz="1150" b="0">
+                <a:solidFill>
+                  <a:srgbClr val="262626"/>
+                </a:solidFill>
+                <a:latin typeface="Arial"/>
+              </a:rPr>
+              <a:t>up to 94% latency reduction vs compressed audio (2025). </a:t>
+            </a:r>
+            <a:r>
+              <a:rPr sz="1150" b="0">
                 <a:solidFill>
                   <a:srgbClr val="0563C1"/>
                 </a:solidFill>
                 <a:latin typeface="Arial"/>
-                <a:hlinkClick r:id="rId10"/>
-              </a:rPr>
-              <a:t>arxiv.org/abs/2211.09536</a:t>
+                <a:hlinkClick r:id="rId9"/>
+              </a:rPr>
+              <a:t>researchgate.net/394380603</a:t>
             </a:r>
           </a:p>
           <a:p>
             <a:pPr>
               <a:lnSpc>
-                <a:spcPct val="102000"/>
+                <a:spcPct val="105000"/>
               </a:lnSpc>
               <a:spcAft>
-                <a:spcPts val="1200"/>
+                <a:spcPts val="1100"/>
               </a:spcAft>
             </a:pPr>
             <a:r>
-              <a:rPr sz="1200" b="1">
+              <a:rPr sz="1150" b="1">
                 <a:solidFill>
                   <a:srgbClr val="262626"/>
                 </a:solidFill>
@@ -10718,45 +10039,45 @@
               <a:t>8. </a:t>
             </a:r>
             <a:r>
-              <a:rPr sz="1200" b="1">
-                <a:solidFill>
-                  <a:srgbClr val="262626"/>
-                </a:solidFill>
-                <a:latin typeface="Arial"/>
-              </a:rPr>
-              <a:t>CER, not WER, for Indic ASR: </a:t>
-            </a:r>
-            <a:r>
-              <a:rPr sz="1200" b="0">
-                <a:solidFill>
-                  <a:srgbClr val="262626"/>
-                </a:solidFill>
-                <a:latin typeface="Arial"/>
-              </a:rPr>
-              <a:t>WER over-punishes agglutinative languages. </a:t>
-            </a:r>
-            <a:r>
-              <a:rPr sz="1200" b="0">
+              <a:rPr sz="1150" b="1">
+                <a:solidFill>
+                  <a:srgbClr val="1F3864"/>
+                </a:solidFill>
+                <a:latin typeface="Arial"/>
+              </a:rPr>
+              <a:t>IndicConformer (AI4Bharat): </a:t>
+            </a:r>
+            <a:r>
+              <a:rPr sz="1150" b="0">
+                <a:solidFill>
+                  <a:srgbClr val="262626"/>
+                </a:solidFill>
+                <a:latin typeface="Arial"/>
+              </a:rPr>
+              <a:t>MIT, all 22 Indian languages, official int8 ONNX; Hindi WER 13.2 (Vaani). </a:t>
+            </a:r>
+            <a:r>
+              <a:rPr sz="1150" b="0">
                 <a:solidFill>
                   <a:srgbClr val="0563C1"/>
                 </a:solidFill>
                 <a:latin typeface="Arial"/>
-                <a:hlinkClick r:id="rId11"/>
-              </a:rPr>
-              <a:t>arxiv.org/abs/2203.16601</a:t>
+                <a:hlinkClick r:id="rId10"/>
+              </a:rPr>
+              <a:t>huggingface.co/ai4bharat</a:t>
             </a:r>
           </a:p>
           <a:p>
             <a:pPr>
               <a:lnSpc>
-                <a:spcPct val="102000"/>
+                <a:spcPct val="105000"/>
               </a:lnSpc>
               <a:spcAft>
-                <a:spcPts val="1200"/>
+                <a:spcPts val="1100"/>
               </a:spcAft>
             </a:pPr>
             <a:r>
-              <a:rPr sz="1200" b="1">
+              <a:rPr sz="1150" b="1">
                 <a:solidFill>
                   <a:srgbClr val="262626"/>
                 </a:solidFill>
@@ -10765,45 +10086,45 @@
               <a:t>9. </a:t>
             </a:r>
             <a:r>
-              <a:rPr sz="1200" b="1">
-                <a:solidFill>
-                  <a:srgbClr val="262626"/>
-                </a:solidFill>
-                <a:latin typeface="Arial"/>
-              </a:rPr>
-              <a:t>J-Alert (Japan): </a:t>
-            </a:r>
-            <a:r>
-              <a:rPr sz="1200" b="0">
-                <a:solidFill>
-                  <a:srgbClr val="262626"/>
-                </a:solidFill>
-                <a:latin typeface="Arial"/>
-              </a:rPr>
-              <a:t>national TTS-spoken disaster alerts in 5 languages. </a:t>
-            </a:r>
-            <a:r>
-              <a:rPr sz="1200" b="0">
+              <a:rPr sz="1150" b="1">
+                <a:solidFill>
+                  <a:srgbClr val="1F3864"/>
+                </a:solidFill>
+                <a:latin typeface="Arial"/>
+              </a:rPr>
+              <a:t>AI4Bharat Indic-TTS: </a:t>
+            </a:r>
+            <a:r>
+              <a:rPr sz="1150" b="0">
+                <a:solidFill>
+                  <a:srgbClr val="262626"/>
+                </a:solidFill>
+                <a:latin typeface="Arial"/>
+              </a:rPr>
+              <a:t>FastPitch + HiFi-GAN, MIT, 13 Indic languages — beats prior open baselines. </a:t>
+            </a:r>
+            <a:r>
+              <a:rPr sz="1150" b="0">
                 <a:solidFill>
                   <a:srgbClr val="0563C1"/>
                 </a:solidFill>
                 <a:latin typeface="Arial"/>
-                <a:hlinkClick r:id="rId12"/>
-              </a:rPr>
-              <a:t>wikipedia.org/wiki/J-Alert</a:t>
+                <a:hlinkClick r:id="rId11"/>
+              </a:rPr>
+              <a:t>arxiv.org/abs/2211.09536</a:t>
             </a:r>
           </a:p>
           <a:p>
             <a:pPr>
               <a:lnSpc>
-                <a:spcPct val="102000"/>
+                <a:spcPct val="105000"/>
               </a:lnSpc>
               <a:spcAft>
-                <a:spcPts val="1200"/>
+                <a:spcPts val="1100"/>
               </a:spcAft>
             </a:pPr>
             <a:r>
-              <a:rPr sz="1200" b="1">
+              <a:rPr sz="1150" b="1">
                 <a:solidFill>
                   <a:srgbClr val="262626"/>
                 </a:solidFill>
@@ -10812,45 +10133,45 @@
               <a:t>10. </a:t>
             </a:r>
             <a:r>
-              <a:rPr sz="1200" b="1">
-                <a:solidFill>
-                  <a:srgbClr val="262626"/>
-                </a:solidFill>
-                <a:latin typeface="Arial"/>
-              </a:rPr>
-              <a:t>IN865 LoRa: </a:t>
-            </a:r>
-            <a:r>
-              <a:rPr sz="1200" b="0">
-                <a:solidFill>
-                  <a:srgbClr val="262626"/>
-                </a:solidFill>
-                <a:latin typeface="Arial"/>
-              </a:rPr>
-              <a:t>865–867 MHz license-free, 1% duty, 30 dBm — km-range at ₹1,650/node. </a:t>
-            </a:r>
-            <a:r>
-              <a:rPr sz="1200" b="0">
+              <a:rPr sz="1150" b="1">
+                <a:solidFill>
+                  <a:srgbClr val="1F3864"/>
+                </a:solidFill>
+                <a:latin typeface="Arial"/>
+              </a:rPr>
+              <a:t>CER, not WER, for Indic ASR: </a:t>
+            </a:r>
+            <a:r>
+              <a:rPr sz="1150" b="0">
+                <a:solidFill>
+                  <a:srgbClr val="262626"/>
+                </a:solidFill>
+                <a:latin typeface="Arial"/>
+              </a:rPr>
+              <a:t>WER disproportionately punishes agglutinative languages. </a:t>
+            </a:r>
+            <a:r>
+              <a:rPr sz="1150" b="0">
                 <a:solidFill>
                   <a:srgbClr val="0563C1"/>
                 </a:solidFill>
                 <a:latin typeface="Arial"/>
-                <a:hlinkClick r:id="rId13"/>
-              </a:rPr>
-              <a:t>ensembletech.in</a:t>
+                <a:hlinkClick r:id="rId12"/>
+              </a:rPr>
+              <a:t>arxiv.org/abs/2203.16601</a:t>
             </a:r>
           </a:p>
           <a:p>
             <a:pPr>
               <a:lnSpc>
-                <a:spcPct val="102000"/>
+                <a:spcPct val="105000"/>
               </a:lnSpc>
               <a:spcAft>
-                <a:spcPts val="1200"/>
+                <a:spcPts val="1100"/>
               </a:spcAft>
             </a:pPr>
             <a:r>
-              <a:rPr sz="1200" b="1">
+              <a:rPr sz="1150" b="1">
                 <a:solidFill>
                   <a:srgbClr val="262626"/>
                 </a:solidFill>
@@ -10859,22 +10180,79 @@
               <a:t>11. </a:t>
             </a:r>
             <a:r>
-              <a:rPr sz="1200" b="1">
-                <a:solidFill>
-                  <a:srgbClr val="262626"/>
-                </a:solidFill>
-                <a:latin typeface="Arial"/>
-              </a:rPr>
-              <a:t>Project repository: </a:t>
-            </a:r>
-            <a:r>
-              <a:rPr sz="1200" b="0">
-                <a:solidFill>
-                  <a:srgbClr val="262626"/>
-                </a:solidFill>
-                <a:latin typeface="Arial"/>
-              </a:rPr>
-              <a:t>app + firmware + evaluation harness + license audit (link added on submission).</a:t>
+              <a:rPr sz="1150" b="1">
+                <a:solidFill>
+                  <a:srgbClr val="1F3864"/>
+                </a:solidFill>
+                <a:latin typeface="Arial"/>
+              </a:rPr>
+              <a:t>J-Alert (Japan): </a:t>
+            </a:r>
+            <a:r>
+              <a:rPr sz="1150" b="0">
+                <a:solidFill>
+                  <a:srgbClr val="262626"/>
+                </a:solidFill>
+                <a:latin typeface="Arial"/>
+              </a:rPr>
+              <a:t>national disaster alerts spoken by TTS in 5 languages, validated at national scale. </a:t>
+            </a:r>
+            <a:r>
+              <a:rPr sz="1150" b="0">
+                <a:solidFill>
+                  <a:srgbClr val="0563C1"/>
+                </a:solidFill>
+                <a:latin typeface="Arial"/>
+                <a:hlinkClick r:id="rId13"/>
+              </a:rPr>
+              <a:t>wikipedia.org/wiki/J-Alert</a:t>
+            </a:r>
+          </a:p>
+          <a:p>
+            <a:pPr>
+              <a:lnSpc>
+                <a:spcPct val="105000"/>
+              </a:lnSpc>
+              <a:spcAft>
+                <a:spcPts val="1100"/>
+              </a:spcAft>
+            </a:pPr>
+            <a:r>
+              <a:rPr sz="1150" b="1">
+                <a:solidFill>
+                  <a:srgbClr val="262626"/>
+                </a:solidFill>
+                <a:latin typeface="Arial"/>
+              </a:rPr>
+              <a:t>12. </a:t>
+            </a:r>
+            <a:r>
+              <a:rPr sz="1150" b="1">
+                <a:solidFill>
+                  <a:srgbClr val="1F3864"/>
+                </a:solidFill>
+                <a:latin typeface="Arial"/>
+              </a:rPr>
+              <a:t>IN865 LoRa legality: </a:t>
+            </a:r>
+            <a:r>
+              <a:rPr sz="1150" b="0">
+                <a:solidFill>
+                  <a:srgbClr val="262626"/>
+                </a:solidFill>
+                <a:latin typeface="Arial"/>
+              </a:rPr>
+              <a:t>865–867 MHz license-free, 1% duty, 30 dBm — km-range at ₹1,650/node. </a:t>
+            </a:r>
+            <a:r>
+              <a:rPr sz="1150" b="0">
+                <a:solidFill>
+                  <a:srgbClr val="0563C1"/>
+                </a:solidFill>
+                <a:latin typeface="Arial"/>
+                <a:hlinkClick r:id="rId14"/>
+              </a:rPr>
+              <a:t>ensembletech.in</a:t>
             </a:r>
           </a:p>
         </p:txBody>
@@ -10887,7 +10265,7 @@
         </p:nvSpPr>
         <p:spPr>
           <a:xfrm>
-            <a:off x="365760" y="5504688"/>
+            <a:off x="365760" y="5541264"/>
             <a:ext cx="11475720" cy="658368"/>
           </a:xfrm>
           <a:prstGeom prst="roundRect">
@@ -10918,43 +10296,34 @@
           </a:fontRef>
         </p:style>
         <p:txBody>
-          <a:bodyPr rtlCol="0" anchor="ctr" wrap="square" tIns="54864"/>
+          <a:bodyPr rtlCol="0" anchor="ctr" wrap="square" bIns="36576"/>
           <a:lstStyle/>
           <a:p>
             <a:pPr algn="ctr">
               <a:lnSpc>
-                <a:spcPct val="100000"/>
+                <a:spcPct val="105000"/>
               </a:lnSpc>
               <a:spcAft>
-                <a:spcPts val="0"/>
+                <a:spcPts val="400"/>
               </a:spcAft>
             </a:pPr>
             <a:r>
-              <a:rPr sz="1200" b="1">
-                <a:solidFill>
-                  <a:srgbClr val="1F3864"/>
-                </a:solidFill>
-                <a:latin typeface="Arial"/>
-              </a:rPr>
-              <a:t>Everything above is reproducible: </a:t>
-            </a:r>
-            <a:r>
-              <a:rPr sz="1200" b="0">
-                <a:solidFill>
-                  <a:srgbClr val="262626"/>
-                </a:solidFill>
-                <a:latin typeface="Arial"/>
-              </a:rPr>
-              <a:t>private repo — 143 protocol assertions · measured CER 1.6% Hindi loop · compiling Android APK (878 KB) — </a:t>
-            </a:r>
-            <a:r>
-              <a:rPr sz="1200" b="1">
+              <a:rPr sz="1150" b="1">
                 <a:solidFill>
                   <a:srgbClr val="C55A11"/>
                 </a:solidFill>
                 <a:latin typeface="Arial"/>
               </a:rPr>
-              <a:t>built before submission, not promised.</a:t>
+              <a:t>Already built: </a:t>
+            </a:r>
+            <a:r>
+              <a:rPr sz="1150" b="1">
+                <a:solidFill>
+                  <a:srgbClr val="262626"/>
+                </a:solidFill>
+                <a:latin typeface="Arial"/>
+              </a:rPr>
+              <a:t>154 protocol assertions green · measured Hindi loop CER 1.6% · Android APK builds (54 MB incl. speech runtime) · Kotlin ↔ Python wire-compatibility proven on 30 test vectors.</a:t>
             </a:r>
           </a:p>
         </p:txBody>

</xml_diff>

<commit_message>
docs: idea PPT v4 — real-speech CER, measured rivals, prosody byte + AFSK modem, AES-GCM, roll-call, WEA/LSSC-ST refs, updated already-built box
</commit_message>
<xml_diff>
--- a/docs/SIH2026-iTantra-idea-PPT.pptx
+++ b/docs/SIH2026-iTantra-idea-PPT.pptx
@@ -6316,7 +6316,7 @@
                 </a:solidFill>
                 <a:latin typeface="Arial"/>
               </a:rPr>
-              <a:t>The app grades itself on stage — live CER · RTF · latency. Measured Hindi round-trip CER: 1.6%.</a:t>
+              <a:t>The app grades itself on stage — live CER · RTF · latency. Measured on real human speech: Hindi CER 2.9%.</a:t>
             </a:r>
           </a:p>
         </p:txBody>
@@ -6618,7 +6618,7 @@
                 </a:solidFill>
                 <a:latin typeface="Arial"/>
               </a:rPr>
-              <a:t>VarnaCode — Indic compression at the entropy floor</a:t>
+              <a:t>Voice through any radio — 0.3 s of sound per sentence (AFSK)</a:t>
             </a:r>
           </a:p>
         </p:txBody>
@@ -6631,8 +6631,8 @@
         </p:nvSpPr>
         <p:spPr>
           <a:xfrm>
-            <a:off x="274320" y="4828032"/>
-            <a:ext cx="11521440" cy="1481328"/>
+            <a:off x="274320" y="4736592"/>
+            <a:ext cx="11521440" cy="1572768"/>
           </a:xfrm>
           <a:prstGeom prst="rect">
             <a:avLst/>
@@ -6647,7 +6647,7 @@
           <a:p>
             <a:pPr>
               <a:spcAft>
-                <a:spcPts val="300"/>
+                <a:spcPts val="200"/>
               </a:spcAft>
             </a:pPr>
             <a:r>
@@ -6666,7 +6666,7 @@
                 <a:spcPct val="100000"/>
               </a:lnSpc>
               <a:spcAft>
-                <a:spcPts val="200"/>
+                <a:spcPts val="150"/>
               </a:spcAft>
             </a:pPr>
             <a:r>
@@ -6685,7 +6685,7 @@
                 </a:solidFill>
                 <a:latin typeface="Arial"/>
               </a:rPr>
-              <a:t>On-device STT with pause-aware sentences: </a:t>
+              <a:t>On-device STT, pause-aware: </a:t>
             </a:r>
             <a:r>
               <a:rPr sz="1050" b="0">
@@ -6703,7 +6703,7 @@
                 <a:spcPct val="100000"/>
               </a:lnSpc>
               <a:spcAft>
-                <a:spcPts val="200"/>
+                <a:spcPts val="150"/>
               </a:spcAft>
             </a:pPr>
             <a:r>
@@ -6731,7 +6731,7 @@
                 </a:solidFill>
                 <a:latin typeface="Arial"/>
               </a:rPr>
-              <a:t>measured 4.45–5.36 bits/char (all 10 languages) — a sentence in ~45 B via Wi-Fi (NSD+TCP) · Bluetooth RFCOMM · ₹1,650 LoRa (km-range, IN865).</a:t>
+              <a:t>4.45–5.41 bits/char measured, beats Unishox2/SCSU — ~45 B/sentence via Wi-Fi · Bluetooth · ₹1,650 LoRa (IN865).</a:t>
             </a:r>
           </a:p>
           <a:p>
@@ -6740,7 +6740,7 @@
                 <a:spcPct val="100000"/>
               </a:lnSpc>
               <a:spcAft>
-                <a:spcPts val="200"/>
+                <a:spcPts val="150"/>
               </a:spcAft>
             </a:pPr>
             <a:r>
@@ -6777,7 +6777,7 @@
                 <a:spcPct val="100000"/>
               </a:lnSpc>
               <a:spcAft>
-                <a:spcPts val="200"/>
+                <a:spcPts val="150"/>
               </a:spcAft>
             </a:pPr>
             <a:r>
@@ -6796,7 +6796,7 @@
                 </a:solidFill>
                 <a:latin typeface="Arial"/>
               </a:rPr>
-              <a:t>Alert mode: </a:t>
+              <a:t>Alert mode + walkie-talkie loop: </a:t>
             </a:r>
             <a:r>
               <a:rPr sz="1050" b="0">
@@ -6805,7 +6805,7 @@
                 </a:solidFill>
                 <a:latin typeface="Arial"/>
               </a:rPr>
-              <a:t>priority frames auto-play at max volume, non-interruptible, with a place-name pronunciation lexicon.</a:t>
+              <a:t>priority frames at max volume, non-interruptible; push-to-talk STT ↔ TTS; app off = normal phone.</a:t>
             </a:r>
           </a:p>
           <a:p>
@@ -6814,7 +6814,7 @@
                 <a:spcPct val="100000"/>
               </a:lnSpc>
               <a:spcAft>
-                <a:spcPts val="200"/>
+                <a:spcPts val="150"/>
               </a:spcAft>
             </a:pPr>
             <a:r>
@@ -6833,7 +6833,7 @@
                 </a:solidFill>
                 <a:latin typeface="Arial"/>
               </a:rPr>
-              <a:t>Walkie-talkie loop: </a:t>
+              <a:t>AES-GCM encrypted: </a:t>
             </a:r>
             <a:r>
               <a:rPr sz="1050" b="0">
@@ -6842,7 +6842,81 @@
                 </a:solidFill>
                 <a:latin typeface="Arial"/>
               </a:rPr>
-              <a:t>two phones, push-to-talk: STT mode ↔ TTS mode; app off = normal phone (the PS verification loop).</a:t>
+              <a:t>an encrypted sentence is 73 B — still 100× under cellular voice; header tampering fails authentication.</a:t>
+            </a:r>
+          </a:p>
+          <a:p>
+            <a:pPr>
+              <a:lnSpc>
+                <a:spcPct val="100000"/>
+              </a:lnSpc>
+              <a:spcAft>
+                <a:spcPts val="150"/>
+              </a:spcAft>
+            </a:pPr>
+            <a:r>
+              <a:rPr sz="1050" b="1">
+                <a:solidFill>
+                  <a:srgbClr val="262626"/>
+                </a:solidFill>
+                <a:latin typeface="Arial"/>
+              </a:rPr>
+              <a:t>6. </a:t>
+            </a:r>
+            <a:r>
+              <a:rPr sz="1050" b="1">
+                <a:solidFill>
+                  <a:srgbClr val="262626"/>
+                </a:solidFill>
+                <a:latin typeface="Arial"/>
+              </a:rPr>
+              <a:t>Prosody survives the bottleneck: </a:t>
+            </a:r>
+            <a:r>
+              <a:rPr sz="1050" b="0">
+                <a:solidFill>
+                  <a:srgbClr val="262626"/>
+                </a:solidFill>
+                <a:latin typeface="Arial"/>
+              </a:rPr>
+              <a:t>a 1-byte urgency code — panic is spoken fast, loud, twice at the far end (STCTS spends 312–592 bps; we spend 8 bits).</a:t>
+            </a:r>
+          </a:p>
+          <a:p>
+            <a:pPr>
+              <a:lnSpc>
+                <a:spcPct val="100000"/>
+              </a:lnSpc>
+              <a:spcAft>
+                <a:spcPts val="150"/>
+              </a:spcAft>
+            </a:pPr>
+            <a:r>
+              <a:rPr sz="1050" b="1">
+                <a:solidFill>
+                  <a:srgbClr val="262626"/>
+                </a:solidFill>
+                <a:latin typeface="Arial"/>
+              </a:rPr>
+              <a:t>7. </a:t>
+            </a:r>
+            <a:r>
+              <a:rPr sz="1050" b="1">
+                <a:solidFill>
+                  <a:srgbClr val="262626"/>
+                </a:solidFill>
+                <a:latin typeface="Arial"/>
+              </a:rPr>
+              <a:t>Works through ANY radio: </a:t>
+            </a:r>
+            <a:r>
+              <a:rPr sz="1050" b="0">
+                <a:solidFill>
+                  <a:srgbClr val="262626"/>
+                </a:solidFill>
+                <a:latin typeface="Arial"/>
+              </a:rPr>
+              <a:t>AFSK software modem turns a frame into 0.3 s of audio — hold the phone to a ₹500 analog walkie-talkie or ham set; survives 6 dB SNR.</a:t>
             </a:r>
           </a:p>
         </p:txBody>
@@ -7511,7 +7585,7 @@
                 </a:solidFill>
                 <a:latin typeface="Arial"/>
               </a:rPr>
-              <a:t>(CER · RTF · compression) → </a:t>
+              <a:t>(CER · RTF · compression) → P1–P5: Android spine → 10 languages + alerts → Evaluation Mode → LoRa bridge + AES-GCM.</a:t>
             </a:r>
           </a:p>
           <a:p>
@@ -7539,7 +7613,7 @@
                 </a:solidFill>
                 <a:latin typeface="Arial"/>
               </a:rPr>
-              <a:t>P1–P5: </a:t>
+              <a:t>Wave-2 features (built, tested): </a:t>
             </a:r>
             <a:r>
               <a:rPr sz="1100" b="0">
@@ -7548,7 +7622,7 @@
                 </a:solidFill>
                 <a:latin typeface="Arial"/>
               </a:rPr>
-              <a:t>Android spine + Hindi loop → 10 languages + alerts → Evaluation Mode → LoRa bridge + AES-GCM.</a:t>
+              <a:t>1-byte prosody code · AFSK any-radio modem · offline digital roll-call · CAP/SACHET last-mile bridge.</a:t>
             </a:r>
           </a:p>
         </p:txBody>
@@ -7647,7 +7721,7 @@
                 </a:solidFill>
                 <a:latin typeface="Arial"/>
               </a:rPr>
-              <a:t>STT RTF 0.055–0.119 · TTS RTF 0.049 · Hindi round-trip CER 1.6% / WER 7.1%</a:t>
+              <a:t>Real human speech (FLEURS, int8 140 MB packs): CER hi 2.9% · bn 4.0% · te 7.8% · ml 9.2% · ta 13.9% · RTF 0.06 · TTS RTF 0.049</a:t>
             </a:r>
           </a:p>
           <a:p>
@@ -7663,7 +7737,7 @@
                 </a:solidFill>
                 <a:latin typeface="Arial"/>
               </a:rPr>
-              <a:t>VarnaCode v1: 4.45–5.36 bits/char across all 10 languages · 154 protocol assertions green</a:t>
+              <a:t>VarnaCode 4.45–5.41 bits/char beats Unishox2/SCSU on all 10 languages (measured head-to-head) · 222 assertions</a:t>
             </a:r>
           </a:p>
           <a:p>
@@ -7679,7 +7753,7 @@
                 </a:solidFill>
                 <a:latin typeface="Arial"/>
               </a:rPr>
-              <a:t>Kotlin ↔ Python wire-compatible · Android APK builds &amp; tests green</a:t>
+              <a:t>AES-GCM encrypted sentence 73 B · Kotlin ↔ Python wire-compatible · APK loop proven on emulators incl. ALERT</a:t>
             </a:r>
           </a:p>
         </p:txBody>
@@ -8349,7 +8423,7 @@
                 </a:solidFill>
                 <a:latin typeface="Arial"/>
               </a:rPr>
-              <a:t>Confidence gate (“repeat that?”), transcript shown on both screens, and a pronunciation lexicon for the highest-stakes alert content.</a:t>
+              <a:t>Confidence gate (“repeat that?”), transcript shown on both screens, and a pronunciation lexicon for the highest-stakes alert content; 5-language real-speech CER 2.9–13.9% measured.</a:t>
             </a:r>
           </a:p>
         </p:txBody>
@@ -8400,7 +8474,7 @@
                 </a:solidFill>
                 <a:latin typeface="Arial"/>
               </a:rPr>
-              <a:t>Wi-Fi Direct flakiness (hotspot+NSD default, BT RFCOMM backup) · Android bg-audio policy (fg-service built first, compiling) · TTS export scope (4 languages, NVIDIA-Riva recipe, eSpeak-NG meanwhile).</a:t>
+              <a:t>Wi-Fi Direct flakiness (hotspot+NSD default, BT RFCOMM backup) · Android bg-audio policy (fg-service built first, compiling) · TTS export scope (4 languages, NVIDIA-Riva recipe, eSpeak-NG meanwhile) · noise: denoiser measured and rejected (hurts Conformer CER) — evidence-driven.</a:t>
             </a:r>
           </a:p>
         </p:txBody>
@@ -9003,7 +9077,7 @@
                 </a:solidFill>
                 <a:latin typeface="Arial"/>
               </a:rPr>
-              <a:t>Research → reality: </a:t>
+              <a:t>Two-way beats broadcast: </a:t>
             </a:r>
             <a:r>
               <a:rPr sz="1050" b="0">
@@ -9012,7 +9086,7 @@
                 </a:solidFill>
                 <a:latin typeface="Arial"/>
               </a:rPr>
-              <a:t>a deployable Indian instance of 6G semantic communication.</a:t>
+              <a:t>Kerala 2018 — 40+ ham operators aided 2,000+ people when towers died; iTantra puts that capability on every phone.</a:t>
             </a:r>
           </a:p>
         </p:txBody>
@@ -9168,7 +9242,7 @@
                 <a:spcPct val="100000"/>
               </a:lnSpc>
               <a:spcAft>
-                <a:spcPts val="250"/>
+                <a:spcPts val="200"/>
               </a:spcAft>
             </a:pPr>
             <a:r>
@@ -9205,7 +9279,7 @@
                 <a:spcPct val="100000"/>
               </a:lnSpc>
               <a:spcAft>
-                <a:spcPts val="250"/>
+                <a:spcPts val="200"/>
               </a:spcAft>
             </a:pPr>
             <a:r>
@@ -9233,7 +9307,7 @@
                 </a:solidFill>
                 <a:latin typeface="Arial"/>
               </a:rPr>
-              <a:t>zero recurring cost (no SIM/server) · sovereign stack: Indian models, IN865 band, no foreign cloud.</a:t>
+              <a:t>zero recurring cost (no SIM/server) · sovereign: Indian models, IN865, no foreign cloud.</a:t>
             </a:r>
           </a:p>
           <a:p>
@@ -9242,7 +9316,7 @@
                 <a:spcPct val="100000"/>
               </a:lnSpc>
               <a:spcAft>
-                <a:spcPts val="250"/>
+                <a:spcPts val="200"/>
               </a:spcAft>
             </a:pPr>
             <a:r>
@@ -9261,6 +9335,43 @@
                 </a:solidFill>
                 <a:latin typeface="Arial"/>
               </a:rPr>
+              <a:t>Offline roll-call: </a:t>
+            </a:r>
+            <a:r>
+              <a:rPr sz="1000" b="0">
+                <a:solidFill>
+                  <a:srgbClr val="262626"/>
+                </a:solidFill>
+                <a:latin typeface="Arial"/>
+              </a:rPr>
+              <a:t>a 9-byte ACK per family = evacuation headcount with no internet.</a:t>
+            </a:r>
+          </a:p>
+          <a:p>
+            <a:pPr>
+              <a:lnSpc>
+                <a:spcPct val="100000"/>
+              </a:lnSpc>
+              <a:spcAft>
+                <a:spcPts val="200"/>
+              </a:spcAft>
+            </a:pPr>
+            <a:r>
+              <a:rPr sz="1000" b="0">
+                <a:solidFill>
+                  <a:srgbClr val="262626"/>
+                </a:solidFill>
+                <a:latin typeface="Arial"/>
+              </a:rPr>
+              <a:t>• </a:t>
+            </a:r>
+            <a:r>
+              <a:rPr sz="1000" b="1">
+                <a:solidFill>
+                  <a:srgbClr val="262626"/>
+                </a:solidFill>
+                <a:latin typeface="Arial"/>
+              </a:rPr>
               <a:t>Operational: </a:t>
             </a:r>
             <a:r>
@@ -9270,7 +9381,7 @@
                 </a:solidFill>
                 <a:latin typeface="Arial"/>
               </a:rPr>
-              <a:t>int8-efficient; LoRa nodes run days on a power bank — solar-deployable in a blackout.</a:t>
+              <a:t>int8-efficient; LoRa nodes run days on a power bank — solar-deployable.</a:t>
             </a:r>
           </a:p>
         </p:txBody>
@@ -9769,11 +9880,11 @@
             <a:r>
               <a:rPr sz="1150" b="1">
                 <a:solidFill>
-                  <a:srgbClr val="C55A11"/>
-                </a:solidFill>
-                <a:latin typeface="Arial"/>
-              </a:rPr>
-              <a:t>Working demo: </a:t>
+                  <a:srgbClr val="1F3864"/>
+                </a:solidFill>
+                <a:latin typeface="Arial"/>
+              </a:rPr>
+              <a:t>Cyclone Amphan outage: </a:t>
             </a:r>
             <a:r>
               <a:rPr sz="1150" b="0">
@@ -9782,7 +9893,17 @@
                 </a:solidFill>
                 <a:latin typeface="Arial"/>
               </a:rPr>
-              <a:t>compiling APK + measured benchmark CSVs live in the repo; demo video added on submission. </a:t>
+              <a:t>~7,000 of 14,167 WB towers down; networks at 65–70% capacity for days (COAI). </a:t>
+            </a:r>
+            <a:r>
+              <a:rPr sz="1150" b="0">
+                <a:solidFill>
+                  <a:srgbClr val="0563C1"/>
+                </a:solidFill>
+                <a:latin typeface="Arial"/>
+                <a:hlinkClick r:id="rId5"/>
+              </a:rPr>
+              <a:t>deccanherald.com</a:t>
             </a:r>
           </a:p>
           <a:p>
@@ -9810,7 +9931,7 @@
                 </a:solidFill>
                 <a:latin typeface="Arial"/>
               </a:rPr>
-              <a:t>Cyclone Amphan outage: </a:t>
+              <a:t>The bitrate math: </a:t>
             </a:r>
             <a:r>
               <a:rPr sz="1150" b="0">
@@ -9819,7 +9940,7 @@
                 </a:solidFill>
                 <a:latin typeface="Arial"/>
               </a:rPr>
-              <a:t>~7,000 of 14,167 WB towers down; networks at 65–70% capacity for days (COAI). </a:t>
+              <a:t>MELPe 600 bps (NATO STANAG 4591) and Codec2 450 bps vs speech-as-text ≈ 107 bps. </a:t>
             </a:r>
             <a:r>
               <a:rPr sz="1150" b="0">
@@ -9827,9 +9948,9 @@
                   <a:srgbClr val="0563C1"/>
                 </a:solidFill>
                 <a:latin typeface="Arial"/>
-                <a:hlinkClick r:id="rId5"/>
-              </a:rPr>
-              <a:t>deccanherald.com</a:t>
+                <a:hlinkClick r:id="rId6"/>
+              </a:rPr>
+              <a:t>melp.org · github.com/drowe67/codec2</a:t>
             </a:r>
           </a:p>
           <a:p>
@@ -9857,7 +9978,7 @@
                 </a:solidFill>
                 <a:latin typeface="Arial"/>
               </a:rPr>
-              <a:t>The bitrate math: </a:t>
+              <a:t>Semantic communications (foundational survey): </a:t>
             </a:r>
             <a:r>
               <a:rPr sz="1150" b="0">
@@ -9866,7 +9987,7 @@
                 </a:solidFill>
                 <a:latin typeface="Arial"/>
               </a:rPr>
-              <a:t>MELPe 600 bps (NATO STANAG 4591) and Codec2 450 bps vs speech-as-text ≈ 107 bps. </a:t>
+              <a:t>Qin, Tao, Lu, Tong &amp; Li, 2021. </a:t>
             </a:r>
             <a:r>
               <a:rPr sz="1150" b="0">
@@ -9874,9 +9995,9 @@
                   <a:srgbClr val="0563C1"/>
                 </a:solidFill>
                 <a:latin typeface="Arial"/>
-                <a:hlinkClick r:id="rId6"/>
-              </a:rPr>
-              <a:t>melp.org · github.com/drowe67/codec2</a:t>
+                <a:hlinkClick r:id="rId7"/>
+              </a:rPr>
+              <a:t>arxiv.org/abs/2201.01389</a:t>
             </a:r>
           </a:p>
           <a:p>
@@ -9904,7 +10025,7 @@
                 </a:solidFill>
                 <a:latin typeface="Arial"/>
               </a:rPr>
-              <a:t>Semantic communications (foundational survey): </a:t>
+              <a:t>DeepSC-ST: </a:t>
             </a:r>
             <a:r>
               <a:rPr sz="1150" b="0">
@@ -9913,7 +10034,7 @@
                 </a:solidFill>
                 <a:latin typeface="Arial"/>
               </a:rPr>
-              <a:t>Qin, Tao, Lu, Tong &amp; Li, 2021. </a:t>
+              <a:t>speech transceiver transmitting recognition-domain features, IEEE Trans. Wireless Comm. 2023. </a:t>
             </a:r>
             <a:r>
               <a:rPr sz="1150" b="0">
@@ -9921,9 +10042,9 @@
                   <a:srgbClr val="0563C1"/>
                 </a:solidFill>
                 <a:latin typeface="Arial"/>
-                <a:hlinkClick r:id="rId7"/>
-              </a:rPr>
-              <a:t>arxiv.org/abs/2201.01389</a:t>
+                <a:hlinkClick r:id="rId8"/>
+              </a:rPr>
+              <a:t>doi.org/10.1109/TWC.2023.3240969</a:t>
             </a:r>
           </a:p>
           <a:p>
@@ -9951,7 +10072,7 @@
                 </a:solidFill>
                 <a:latin typeface="Arial"/>
               </a:rPr>
-              <a:t>DeepSC-ST: </a:t>
+              <a:t>STT over low-data-rate networks: </a:t>
             </a:r>
             <a:r>
               <a:rPr sz="1150" b="0">
@@ -9960,7 +10081,7 @@
                 </a:solidFill>
                 <a:latin typeface="Arial"/>
               </a:rPr>
-              <a:t>speech transceiver transmitting recognition-domain features, IEEE Trans. Wireless Comm. 2023. </a:t>
+              <a:t>up to 94% latency reduction vs compressed audio (2025). </a:t>
             </a:r>
             <a:r>
               <a:rPr sz="1150" b="0">
@@ -9968,9 +10089,9 @@
                   <a:srgbClr val="0563C1"/>
                 </a:solidFill>
                 <a:latin typeface="Arial"/>
-                <a:hlinkClick r:id="rId8"/>
-              </a:rPr>
-              <a:t>doi.org/10.1109/TWC.2023.3240969</a:t>
+                <a:hlinkClick r:id="rId9"/>
+              </a:rPr>
+              <a:t>researchgate.net/394380603</a:t>
             </a:r>
           </a:p>
           <a:p>
@@ -9998,7 +10119,7 @@
                 </a:solidFill>
                 <a:latin typeface="Arial"/>
               </a:rPr>
-              <a:t>STT over low-data-rate networks: </a:t>
+              <a:t>IndicConformer (AI4Bharat): </a:t>
             </a:r>
             <a:r>
               <a:rPr sz="1150" b="0">
@@ -10007,7 +10128,7 @@
                 </a:solidFill>
                 <a:latin typeface="Arial"/>
               </a:rPr>
-              <a:t>up to 94% latency reduction vs compressed audio (2025). </a:t>
+              <a:t>MIT, all 22 Indian languages, official int8 ONNX; Hindi WER 13.2 (Vaani). </a:t>
             </a:r>
             <a:r>
               <a:rPr sz="1150" b="0">
@@ -10015,9 +10136,9 @@
                   <a:srgbClr val="0563C1"/>
                 </a:solidFill>
                 <a:latin typeface="Arial"/>
-                <a:hlinkClick r:id="rId9"/>
-              </a:rPr>
-              <a:t>researchgate.net/394380603</a:t>
+                <a:hlinkClick r:id="rId10"/>
+              </a:rPr>
+              <a:t>huggingface.co/ai4bharat</a:t>
             </a:r>
           </a:p>
           <a:p>
@@ -10045,7 +10166,7 @@
                 </a:solidFill>
                 <a:latin typeface="Arial"/>
               </a:rPr>
-              <a:t>IndicConformer (AI4Bharat): </a:t>
+              <a:t>AI4Bharat Indic-TTS: </a:t>
             </a:r>
             <a:r>
               <a:rPr sz="1150" b="0">
@@ -10054,7 +10175,7 @@
                 </a:solidFill>
                 <a:latin typeface="Arial"/>
               </a:rPr>
-              <a:t>MIT, all 22 Indian languages, official int8 ONNX; Hindi WER 13.2 (Vaani). </a:t>
+              <a:t>FastPitch + HiFi-GAN, MIT, 13 Indic languages — beats prior open baselines. </a:t>
             </a:r>
             <a:r>
               <a:rPr sz="1150" b="0">
@@ -10062,9 +10183,9 @@
                   <a:srgbClr val="0563C1"/>
                 </a:solidFill>
                 <a:latin typeface="Arial"/>
-                <a:hlinkClick r:id="rId10"/>
-              </a:rPr>
-              <a:t>huggingface.co/ai4bharat</a:t>
+                <a:hlinkClick r:id="rId11"/>
+              </a:rPr>
+              <a:t>arxiv.org/abs/2211.09536</a:t>
             </a:r>
           </a:p>
           <a:p>
@@ -10092,7 +10213,7 @@
                 </a:solidFill>
                 <a:latin typeface="Arial"/>
               </a:rPr>
-              <a:t>AI4Bharat Indic-TTS: </a:t>
+              <a:t>CER, not WER, for Indic ASR: </a:t>
             </a:r>
             <a:r>
               <a:rPr sz="1150" b="0">
@@ -10101,7 +10222,7 @@
                 </a:solidFill>
                 <a:latin typeface="Arial"/>
               </a:rPr>
-              <a:t>FastPitch + HiFi-GAN, MIT, 13 Indic languages — beats prior open baselines. </a:t>
+              <a:t>WER disproportionately punishes agglutinative languages. </a:t>
             </a:r>
             <a:r>
               <a:rPr sz="1150" b="0">
@@ -10109,9 +10230,9 @@
                   <a:srgbClr val="0563C1"/>
                 </a:solidFill>
                 <a:latin typeface="Arial"/>
-                <a:hlinkClick r:id="rId11"/>
-              </a:rPr>
-              <a:t>arxiv.org/abs/2211.09536</a:t>
+                <a:hlinkClick r:id="rId12"/>
+              </a:rPr>
+              <a:t>arxiv.org/abs/2203.16601</a:t>
             </a:r>
           </a:p>
           <a:p>
@@ -10139,7 +10260,7 @@
                 </a:solidFill>
                 <a:latin typeface="Arial"/>
               </a:rPr>
-              <a:t>CER, not WER, for Indic ASR: </a:t>
+              <a:t>WEA message-length study (2024): </a:t>
             </a:r>
             <a:r>
               <a:rPr sz="1150" b="0">
@@ -10148,7 +10269,7 @@
                 </a:solidFill>
                 <a:latin typeface="Arial"/>
               </a:rPr>
-              <a:t>WER disproportionately punishes agglutinative languages. </a:t>
+              <a:t>360-char alerts no better than 90-char (N=481) — validates the 45-byte design. </a:t>
             </a:r>
             <a:r>
               <a:rPr sz="1150" b="0">
@@ -10156,9 +10277,9 @@
                   <a:srgbClr val="0563C1"/>
                 </a:solidFill>
                 <a:latin typeface="Arial"/>
-                <a:hlinkClick r:id="rId12"/>
-              </a:rPr>
-              <a:t>arxiv.org/abs/2203.16601</a:t>
+                <a:hlinkClick r:id="rId13"/>
+              </a:rPr>
+              <a:t>pmc.ncbi.nlm.nih.gov/PMC11424238</a:t>
             </a:r>
           </a:p>
           <a:p>
@@ -10186,7 +10307,7 @@
                 </a:solidFill>
                 <a:latin typeface="Arial"/>
               </a:rPr>
-              <a:t>J-Alert (Japan): </a:t>
+              <a:t>LSSC-ST semantic speech transmission (2025): </a:t>
             </a:r>
             <a:r>
               <a:rPr sz="1150" b="0">
@@ -10195,7 +10316,7 @@
                 </a:solidFill>
                 <a:latin typeface="Arial"/>
               </a:rPr>
-              <a:t>national disaster alerts spoken by TTS in 5 languages, validated at national scale. </a:t>
+              <a:t>needs an edge server; iTantra is fully offline. </a:t>
             </a:r>
             <a:r>
               <a:rPr sz="1150" b="0">
@@ -10203,9 +10324,9 @@
                   <a:srgbClr val="0563C1"/>
                 </a:solidFill>
                 <a:latin typeface="Arial"/>
-                <a:hlinkClick r:id="rId13"/>
-              </a:rPr>
-              <a:t>wikipedia.org/wiki/J-Alert</a:t>
+                <a:hlinkClick r:id="rId14"/>
+              </a:rPr>
+              <a:t>arxiv.org/abs/2501.05859</a:t>
             </a:r>
           </a:p>
           <a:p>
@@ -10250,7 +10371,7 @@
                   <a:srgbClr val="0563C1"/>
                 </a:solidFill>
                 <a:latin typeface="Arial"/>
-                <a:hlinkClick r:id="rId14"/>
+                <a:hlinkClick r:id="rId15"/>
               </a:rPr>
               <a:t>ensembletech.in</a:t>
             </a:r>
@@ -10323,7 +10444,7 @@
                 </a:solidFill>
                 <a:latin typeface="Arial"/>
               </a:rPr>
-              <a:t>154 protocol assertions green · measured Hindi loop CER 1.6% · Android APK builds (54 MB incl. speech runtime) · Kotlin ↔ Python wire-compatibility proven on 30 test vectors.</a:t>
+              <a:t>222 protocol assertions · real-speech CER 2.9% Hindi · 5 language packs converted · Android APK loop proven on emulators incl. ALERT · AES-GCM + prosody byte on the wire · LoRa firmware compiles · AFSK modem, roll-call, CAP bridge tested.</a:t>
             </a:r>
           </a:p>
         </p:txBody>

</xml_diff>